<commit_message>
Slides: use the lesson's own wording for the seven areas in the sd-10-003 deck
Co-Authored-By: Claude Sonnet 5.5 <noreply@anthropic.com>
Claude-Session: https://claude.ai/code/session_01E4oCkXXqBf2c7oMUzFxEr2
</commit_message>
<xml_diff>
--- a/system-design-101/vi/lessons/sd-10-003/slides/sd-10-003.pptx
+++ b/system-design-101/vi/lessons/sd-10-003/slides/sd-10-003.pptx
@@ -5526,6 +5526,72 @@
               <a:t> diện</a:t>
             </a:r>
             <a:r>
+              <a:rPr lang="en-US" sz="2550" dirty="0" spc="-17" kern="0">
+                <a:solidFill>
+                  <a:srgbClr val="14161C"/>
+                </a:solidFill>
+                <a:latin typeface="Be Vietnam Pro" pitchFamily="34" charset="0"/>
+                <a:ea typeface="Be Vietnam Pro" pitchFamily="34" charset="-122"/>
+                <a:cs typeface="Be Vietnam Pro" pitchFamily="34" charset="-120"/>
+              </a:rPr>
+              <a:t> quyết</a:t>
+            </a:r>
+            <a:r>
+              <a:rPr lang="en-US" sz="2550" dirty="0" spc="21" kern="0">
+                <a:solidFill>
+                  <a:srgbClr val="14161C"/>
+                </a:solidFill>
+                <a:latin typeface="Be Vietnam Pro" pitchFamily="34" charset="0"/>
+                <a:ea typeface="Be Vietnam Pro" pitchFamily="34" charset="-122"/>
+                <a:cs typeface="Be Vietnam Pro" pitchFamily="34" charset="-120"/>
+              </a:rPr>
+              <a:t> định</a:t>
+            </a:r>
+            <a:r>
+              <a:rPr lang="en-US" sz="2550" dirty="0" spc="-5" kern="0">
+                <a:solidFill>
+                  <a:srgbClr val="14161C"/>
+                </a:solidFill>
+                <a:latin typeface="Be Vietnam Pro" pitchFamily="34" charset="0"/>
+                <a:ea typeface="Be Vietnam Pro" pitchFamily="34" charset="-122"/>
+                <a:cs typeface="Be Vietnam Pro" pitchFamily="34" charset="-120"/>
+              </a:rPr>
+              <a:t> bố</a:t>
+            </a:r>
+            <a:r>
+              <a:rPr lang="en-US" sz="2550" dirty="0" spc="-1" kern="0">
+                <a:solidFill>
+                  <a:srgbClr val="14161C"/>
+                </a:solidFill>
+                <a:latin typeface="Be Vietnam Pro" pitchFamily="34" charset="0"/>
+                <a:ea typeface="Be Vietnam Pro" pitchFamily="34" charset="-122"/>
+                <a:cs typeface="Be Vietnam Pro" pitchFamily="34" charset="-120"/>
+              </a:rPr>
+              <a:t> cục</a:t>
+            </a:r>
+            <a:r>
+              <a:rPr lang="en-US" sz="2550" dirty="0" spc="-19" kern="0">
+                <a:solidFill>
+                  <a:srgbClr val="14161C"/>
+                </a:solidFill>
+                <a:latin typeface="Be Vietnam Pro" pitchFamily="34" charset="0"/>
+                <a:ea typeface="Be Vietnam Pro" pitchFamily="34" charset="-122"/>
+                <a:cs typeface="Be Vietnam Pro" pitchFamily="34" charset="-120"/>
+              </a:rPr>
+              <a:t> và</a:t>
+            </a:r>
+            <a:r>
+              <a:rPr lang="en-US" sz="2550" dirty="0" spc="1" kern="0">
+                <a:solidFill>
+                  <a:srgbClr val="14161C"/>
+                </a:solidFill>
+                <a:latin typeface="Be Vietnam Pro" pitchFamily="34" charset="0"/>
+                <a:ea typeface="Be Vietnam Pro" pitchFamily="34" charset="-122"/>
+                <a:cs typeface="Be Vietnam Pro" pitchFamily="34" charset="-120"/>
+              </a:rPr>
+              <a:t> luồng</a:t>
+            </a:r>
+            <a:r>
               <a:rPr lang="en-US" sz="2550" dirty="0" spc="0" kern="0">
                 <a:solidFill>
                   <a:srgbClr val="14161C"/>
@@ -5534,106 +5600,18 @@
                 <a:ea typeface="Be Vietnam Pro" pitchFamily="34" charset="-122"/>
                 <a:cs typeface="Be Vietnam Pro" pitchFamily="34" charset="-120"/>
               </a:rPr>
-              <a:t> lo</a:t>
-            </a:r>
-            <a:r>
-              <a:rPr lang="en-US" sz="2550" dirty="0" spc="24" kern="0">
-                <a:solidFill>
-                  <a:srgbClr val="14161C"/>
-                </a:solidFill>
-                <a:latin typeface="Be Vietnam Pro" pitchFamily="34" charset="0"/>
-                <a:ea typeface="Be Vietnam Pro" pitchFamily="34" charset="-122"/>
-                <a:cs typeface="Be Vietnam Pro" pitchFamily="34" charset="-120"/>
-              </a:rPr>
-              <a:t> ứng</a:t>
-            </a:r>
-            <a:r>
-              <a:rPr lang="en-US" sz="2550" dirty="0" spc="-1" kern="0">
-                <a:solidFill>
-                  <a:srgbClr val="14161C"/>
-                </a:solidFill>
-                <a:latin typeface="Be Vietnam Pro" pitchFamily="34" charset="0"/>
-                <a:ea typeface="Be Vietnam Pro" pitchFamily="34" charset="-122"/>
-                <a:cs typeface="Be Vietnam Pro" pitchFamily="34" charset="-120"/>
-              </a:rPr>
-              <a:t> dụng</a:t>
-            </a:r>
-            <a:r>
-              <a:rPr lang="en-US" sz="2550" dirty="0" spc="-16" kern="0">
-                <a:solidFill>
-                  <a:srgbClr val="14161C"/>
-                </a:solidFill>
-                <a:latin typeface="Be Vietnam Pro" pitchFamily="34" charset="0"/>
-                <a:ea typeface="Be Vietnam Pro" pitchFamily="34" charset="-122"/>
-                <a:cs typeface="Be Vietnam Pro" pitchFamily="34" charset="-120"/>
-              </a:rPr>
-              <a:t> trông</a:t>
-            </a:r>
-            <a:r>
-              <a:rPr lang="en-US" sz="2550" dirty="0" spc="1" kern="0">
-                <a:solidFill>
-                  <a:srgbClr val="14161C"/>
-                </a:solidFill>
-                <a:latin typeface="Be Vietnam Pro" pitchFamily="34" charset="0"/>
-                <a:ea typeface="Be Vietnam Pro" pitchFamily="34" charset="-122"/>
-                <a:cs typeface="Be Vietnam Pro" pitchFamily="34" charset="-120"/>
-              </a:rPr>
-              <a:t> thế</a:t>
-            </a:r>
-            <a:r>
-              <a:rPr lang="en-US" sz="2550" dirty="0" spc="0" kern="0">
-                <a:solidFill>
-                  <a:srgbClr val="14161C"/>
-                </a:solidFill>
-                <a:latin typeface="Be Vietnam Pro" pitchFamily="34" charset="0"/>
-                <a:ea typeface="Be Vietnam Pro" pitchFamily="34" charset="-122"/>
-                <a:cs typeface="Be Vietnam Pro" pitchFamily="34" charset="-120"/>
-              </a:rPr>
-              <a:t> nào</a:t>
-            </a:r>
-            <a:r>
-              <a:rPr lang="en-US" sz="2550" dirty="0" spc="-19" kern="0">
-                <a:solidFill>
-                  <a:srgbClr val="14161C"/>
-                </a:solidFill>
-                <a:latin typeface="Be Vietnam Pro" pitchFamily="34" charset="0"/>
-                <a:ea typeface="Be Vietnam Pro" pitchFamily="34" charset="-122"/>
-                <a:cs typeface="Be Vietnam Pro" pitchFamily="34" charset="-120"/>
-              </a:rPr>
-              <a:t> và</a:t>
-            </a:r>
-            <a:r>
-              <a:rPr lang="en-US" sz="2550" dirty="0" spc="-1" kern="0">
-                <a:solidFill>
-                  <a:srgbClr val="14161C"/>
-                </a:solidFill>
-                <a:latin typeface="Be Vietnam Pro" pitchFamily="34" charset="0"/>
-                <a:ea typeface="Be Vietnam Pro" pitchFamily="34" charset="-122"/>
-                <a:cs typeface="Be Vietnam Pro" pitchFamily="34" charset="-120"/>
-              </a:rPr>
-              <a:t> dùng</a:t>
-            </a:r>
-            <a:r>
-              <a:rPr lang="en-US" sz="2550" dirty="0" spc="-35" kern="0">
-                <a:solidFill>
-                  <a:srgbClr val="14161C"/>
-                </a:solidFill>
-                <a:latin typeface="Be Vietnam Pro" pitchFamily="34" charset="0"/>
-                <a:ea typeface="Be Vietnam Pro" pitchFamily="34" charset="-122"/>
-                <a:cs typeface="Be Vietnam Pro" pitchFamily="34" charset="-120"/>
-              </a:rPr>
-              <a:t> ra</a:t>
-            </a:r>
-            <a:r>
-              <a:rPr lang="en-US" sz="2550" dirty="0" spc="-5" kern="0">
-                <a:solidFill>
-                  <a:srgbClr val="14161C"/>
-                </a:solidFill>
-                <a:latin typeface="Be Vietnam Pro" pitchFamily="34" charset="0"/>
-                <a:ea typeface="Be Vietnam Pro" pitchFamily="34" charset="-122"/>
-                <a:cs typeface="Be Vietnam Pro" pitchFamily="34" charset="-120"/>
-              </a:rPr>
-              <a:t> sao.</a:t>
+              <a:t> thao</a:t>
+            </a:r>
+            <a:r>
+              <a:rPr lang="en-US" sz="2550" dirty="0" spc="-8" kern="0">
+                <a:solidFill>
+                  <a:srgbClr val="14161C"/>
+                </a:solidFill>
+                <a:latin typeface="Be Vietnam Pro" pitchFamily="34" charset="0"/>
+                <a:ea typeface="Be Vietnam Pro" pitchFamily="34" charset="-122"/>
+                <a:cs typeface="Be Vietnam Pro" pitchFamily="34" charset="-120"/>
+              </a:rPr>
+              <a:t> tác.</a:t>
             </a:r>
             <a:endParaRPr lang="en-US" sz="2550" dirty="0"/>
           </a:p>
@@ -5782,26 +5760,70 @@
               <a:buNone/>
             </a:pPr>
             <a:r>
-              <a:rPr lang="en-US" sz="2250" dirty="0" spc="-71" kern="0">
-                <a:solidFill>
-                  <a:srgbClr val="14161C"/>
-                </a:solidFill>
-                <a:latin typeface="Be Vietnam Pro" pitchFamily="34" charset="0"/>
-                <a:ea typeface="Be Vietnam Pro" pitchFamily="34" charset="-122"/>
-                <a:cs typeface="Be Vietnam Pro" pitchFamily="34" charset="-120"/>
-              </a:rPr>
-              <a:t>Tạo</a:t>
-            </a:r>
-            <a:r>
-              <a:rPr lang="en-US" sz="2250" dirty="0" spc="-3" kern="0">
-                <a:solidFill>
-                  <a:srgbClr val="14161C"/>
-                </a:solidFill>
-                <a:latin typeface="Be Vietnam Pro" pitchFamily="34" charset="0"/>
-                <a:ea typeface="Be Vietnam Pro" pitchFamily="34" charset="-122"/>
-                <a:cs typeface="Be Vietnam Pro" pitchFamily="34" charset="-120"/>
-              </a:rPr>
-              <a:t> giao</a:t>
+              <a:rPr lang="en-US" sz="2250" dirty="0" spc="-12" kern="0">
+                <a:solidFill>
+                  <a:srgbClr val="14161C"/>
+                </a:solidFill>
+                <a:latin typeface="Be Vietnam Pro" pitchFamily="34" charset="0"/>
+                <a:ea typeface="Be Vietnam Pro" pitchFamily="34" charset="-122"/>
+                <a:cs typeface="Be Vietnam Pro" pitchFamily="34" charset="-120"/>
+              </a:rPr>
+              <a:t>Chạy</a:t>
+            </a:r>
+            <a:r>
+              <a:rPr lang="en-US" sz="2250" dirty="0" spc="-16" kern="0">
+                <a:solidFill>
+                  <a:srgbClr val="14161C"/>
+                </a:solidFill>
+                <a:latin typeface="Be Vietnam Pro" pitchFamily="34" charset="0"/>
+                <a:ea typeface="Be Vietnam Pro" pitchFamily="34" charset="-122"/>
+                <a:cs typeface="Be Vietnam Pro" pitchFamily="34" charset="-120"/>
+              </a:rPr>
+              <a:t> trong</a:t>
+            </a:r>
+            <a:r>
+              <a:rPr lang="en-US" sz="2250" dirty="0" spc="7" kern="0">
+                <a:solidFill>
+                  <a:srgbClr val="14161C"/>
+                </a:solidFill>
+                <a:latin typeface="Be Vietnam Pro" pitchFamily="34" charset="0"/>
+                <a:ea typeface="Be Vietnam Pro" pitchFamily="34" charset="-122"/>
+                <a:cs typeface="Be Vietnam Pro" pitchFamily="34" charset="-120"/>
+              </a:rPr>
+              <a:t> trình</a:t>
+            </a:r>
+            <a:r>
+              <a:rPr lang="en-US" sz="2250" dirty="0" spc="-13" kern="0">
+                <a:solidFill>
+                  <a:srgbClr val="14161C"/>
+                </a:solidFill>
+                <a:latin typeface="Be Vietnam Pro" pitchFamily="34" charset="0"/>
+                <a:ea typeface="Be Vietnam Pro" pitchFamily="34" charset="-122"/>
+                <a:cs typeface="Be Vietnam Pro" pitchFamily="34" charset="-120"/>
+              </a:rPr>
+              <a:t> duyệt:</a:t>
+            </a:r>
+            <a:r>
+              <a:rPr lang="en-US" sz="2250" dirty="0" spc="-1" kern="0">
+                <a:solidFill>
+                  <a:srgbClr val="14161C"/>
+                </a:solidFill>
+                <a:latin typeface="Be Vietnam Pro" pitchFamily="34" charset="0"/>
+                <a:ea typeface="Be Vietnam Pro" pitchFamily="34" charset="-122"/>
+                <a:cs typeface="Be Vietnam Pro" pitchFamily="34" charset="-120"/>
+              </a:rPr>
+              <a:t> HTML</a:t>
+            </a:r>
+            <a:r>
+              <a:rPr lang="en-US" sz="2250" dirty="0" spc="21" kern="0">
+                <a:solidFill>
+                  <a:srgbClr val="14161C"/>
+                </a:solidFill>
+                <a:latin typeface="Be Vietnam Pro" pitchFamily="34" charset="0"/>
+                <a:ea typeface="Be Vietnam Pro" pitchFamily="34" charset="-122"/>
+                <a:cs typeface="Be Vietnam Pro" pitchFamily="34" charset="-120"/>
+              </a:rPr>
+              <a:t> dựng</a:t>
             </a:r>
             <a:r>
               <a:rPr lang="en-US" sz="2250" dirty="0" spc="0" kern="0">
@@ -5812,84 +5834,73 @@
                 <a:ea typeface="Be Vietnam Pro" pitchFamily="34" charset="-122"/>
                 <a:cs typeface="Be Vietnam Pro" pitchFamily="34" charset="-120"/>
               </a:rPr>
-              <a:t> diện</a:t>
-            </a:r>
-            <a:r>
-              <a:rPr lang="en-US" sz="2250" dirty="0" spc="-17" kern="0">
-                <a:solidFill>
-                  <a:srgbClr val="14161C"/>
-                </a:solidFill>
-                <a:latin typeface="Be Vietnam Pro" pitchFamily="34" charset="0"/>
-                <a:ea typeface="Be Vietnam Pro" pitchFamily="34" charset="-122"/>
-                <a:cs typeface="Be Vietnam Pro" pitchFamily="34" charset="-120"/>
-              </a:rPr>
-              <a:t> và</a:t>
-            </a:r>
-            <a:r>
-              <a:rPr lang="en-US" sz="2250" dirty="0" spc="-20" kern="0">
-                <a:solidFill>
-                  <a:srgbClr val="14161C"/>
-                </a:solidFill>
-                <a:latin typeface="Be Vietnam Pro" pitchFamily="34" charset="0"/>
-                <a:ea typeface="Be Vietnam Pro" pitchFamily="34" charset="-122"/>
-                <a:cs typeface="Be Vietnam Pro" pitchFamily="34" charset="-120"/>
-              </a:rPr>
-              <a:t> trải</a:t>
-            </a:r>
-            <a:r>
-              <a:rPr lang="en-US" sz="2250" dirty="0" spc="-2" kern="0">
-                <a:solidFill>
-                  <a:srgbClr val="14161C"/>
-                </a:solidFill>
-                <a:latin typeface="Be Vietnam Pro" pitchFamily="34" charset="0"/>
-                <a:ea typeface="Be Vietnam Pro" pitchFamily="34" charset="-122"/>
-                <a:cs typeface="Be Vietnam Pro" pitchFamily="34" charset="-120"/>
-              </a:rPr>
-              <a:t> nghiệm</a:t>
-            </a:r>
-            <a:r>
-              <a:rPr lang="en-US" sz="2250" dirty="0" spc="3" kern="0">
-                <a:solidFill>
-                  <a:srgbClr val="14161C"/>
-                </a:solidFill>
-                <a:latin typeface="Be Vietnam Pro" pitchFamily="34" charset="0"/>
-                <a:ea typeface="Be Vietnam Pro" pitchFamily="34" charset="-122"/>
-                <a:cs typeface="Be Vietnam Pro" pitchFamily="34" charset="-120"/>
-              </a:rPr>
-              <a:t> của</a:t>
-            </a:r>
-            <a:r>
-              <a:rPr lang="en-US" sz="2250" dirty="0" spc="24" kern="0">
-                <a:solidFill>
-                  <a:srgbClr val="14161C"/>
-                </a:solidFill>
-                <a:latin typeface="Be Vietnam Pro" pitchFamily="34" charset="0"/>
-                <a:ea typeface="Be Vietnam Pro" pitchFamily="34" charset="-122"/>
-                <a:cs typeface="Be Vietnam Pro" pitchFamily="34" charset="-120"/>
-              </a:rPr>
-              <a:t> ứng</a:t>
-            </a:r>
-            <a:r>
-              <a:rPr lang="en-US" sz="2250" dirty="0" spc="3" kern="0">
-                <a:solidFill>
-                  <a:srgbClr val="14161C"/>
-                </a:solidFill>
-                <a:latin typeface="Be Vietnam Pro" pitchFamily="34" charset="0"/>
-                <a:ea typeface="Be Vietnam Pro" pitchFamily="34" charset="-122"/>
-                <a:cs typeface="Be Vietnam Pro" pitchFamily="34" charset="-120"/>
-              </a:rPr>
-              <a:t> dụng</a:t>
-            </a:r>
-            <a:r>
-              <a:rPr lang="en-US" sz="2250" dirty="0" spc="-8" kern="0">
-                <a:solidFill>
-                  <a:srgbClr val="14161C"/>
-                </a:solidFill>
-                <a:latin typeface="Be Vietnam Pro" pitchFamily="34" charset="0"/>
-                <a:ea typeface="Be Vietnam Pro" pitchFamily="34" charset="-122"/>
-                <a:cs typeface="Be Vietnam Pro" pitchFamily="34" charset="-120"/>
-              </a:rPr>
-              <a:t> web.</a:t>
+              <a:t> cấu</a:t>
+            </a:r>
+            <a:r>
+              <a:rPr lang="en-US" sz="2250" dirty="0" spc="1" kern="0">
+                <a:solidFill>
+                  <a:srgbClr val="14161C"/>
+                </a:solidFill>
+                <a:latin typeface="Be Vietnam Pro" pitchFamily="34" charset="0"/>
+                <a:ea typeface="Be Vietnam Pro" pitchFamily="34" charset="-122"/>
+                <a:cs typeface="Be Vietnam Pro" pitchFamily="34" charset="-120"/>
+              </a:rPr>
+              <a:t> trúc, CSS</a:t>
+            </a:r>
+            <a:r>
+              <a:rPr lang="en-US" sz="2250" dirty="0" spc="-12" kern="0">
+                <a:solidFill>
+                  <a:srgbClr val="14161C"/>
+                </a:solidFill>
+                <a:latin typeface="Be Vietnam Pro" pitchFamily="34" charset="0"/>
+                <a:ea typeface="Be Vietnam Pro" pitchFamily="34" charset="-122"/>
+                <a:cs typeface="Be Vietnam Pro" pitchFamily="34" charset="-120"/>
+              </a:rPr>
+              <a:t> tạo</a:t>
+            </a:r>
+            <a:r>
+              <a:rPr lang="en-US" sz="2250" dirty="0" spc="-1" kern="0">
+                <a:solidFill>
+                  <a:srgbClr val="14161C"/>
+                </a:solidFill>
+                <a:latin typeface="Be Vietnam Pro" pitchFamily="34" charset="0"/>
+                <a:ea typeface="Be Vietnam Pro" pitchFamily="34" charset="-122"/>
+                <a:cs typeface="Be Vietnam Pro" pitchFamily="34" charset="-120"/>
+              </a:rPr>
+              <a:t> dáng,</a:t>
+            </a:r>
+            <a:r>
+              <a:rPr lang="en-US" sz="2250" dirty="0" spc="-7" kern="0">
+                <a:solidFill>
+                  <a:srgbClr val="14161C"/>
+                </a:solidFill>
+                <a:latin typeface="Be Vietnam Pro" pitchFamily="34" charset="0"/>
+                <a:ea typeface="Be Vietnam Pro" pitchFamily="34" charset="-122"/>
+                <a:cs typeface="Be Vietnam Pro" pitchFamily="34" charset="-120"/>
+              </a:rPr>
+              <a:t> JavaScript</a:t>
+            </a:r>
+            <a:r>
+              <a:rPr lang="en-US" sz="2250" dirty="0" spc="-13" kern="0">
+                <a:solidFill>
+                  <a:srgbClr val="14161C"/>
+                </a:solidFill>
+                <a:latin typeface="Be Vietnam Pro" pitchFamily="34" charset="0"/>
+                <a:ea typeface="Be Vietnam Pro" pitchFamily="34" charset="-122"/>
+                <a:cs typeface="Be Vietnam Pro" pitchFamily="34" charset="-120"/>
+              </a:rPr>
+              <a:t> tạo</a:t>
+            </a:r>
+            <a:r>
+              <a:rPr lang="en-US" sz="2250" dirty="0" spc="0" kern="0">
+                <a:solidFill>
+                  <a:srgbClr val="14161C"/>
+                </a:solidFill>
+                <a:latin typeface="Be Vietnam Pro" pitchFamily="34" charset="0"/>
+                <a:ea typeface="Be Vietnam Pro" pitchFamily="34" charset="-122"/>
+                <a:cs typeface="Be Vietnam Pro" pitchFamily="34" charset="-120"/>
+              </a:rPr>
+              <a:t> hành vi.</a:t>
             </a:r>
             <a:endParaRPr lang="en-US" sz="2250" dirty="0"/>
           </a:p>
@@ -6022,18 +6033,73 @@
               <a:buNone/>
             </a:pPr>
             <a:r>
-              <a:rPr lang="en-US" sz="2250" dirty="0" spc="-71" kern="0">
-                <a:solidFill>
-                  <a:srgbClr val="14161C"/>
-                </a:solidFill>
-                <a:latin typeface="Be Vietnam Pro" pitchFamily="34" charset="0"/>
-                <a:ea typeface="Be Vietnam Pro" pitchFamily="34" charset="-122"/>
-                <a:cs typeface="Be Vietnam Pro" pitchFamily="34" charset="-120"/>
-              </a:rPr>
-              <a:t>Tạo</a:t>
-            </a:r>
-            <a:r>
-              <a:rPr lang="en-US" sz="2250" dirty="0" spc="24" kern="0">
+              <a:rPr lang="en-US" sz="2250" dirty="0" spc="-1" kern="0">
+                <a:solidFill>
+                  <a:srgbClr val="14161C"/>
+                </a:solidFill>
+                <a:latin typeface="Be Vietnam Pro" pitchFamily="34" charset="0"/>
+                <a:ea typeface="Be Vietnam Pro" pitchFamily="34" charset="-122"/>
+                <a:cs typeface="Be Vietnam Pro" pitchFamily="34" charset="-120"/>
+              </a:rPr>
+              <a:t>Cùng</a:t>
+            </a:r>
+            <a:r>
+              <a:rPr lang="en-US" sz="2250" dirty="0" spc="10" kern="0">
+                <a:solidFill>
+                  <a:srgbClr val="14161C"/>
+                </a:solidFill>
+                <a:latin typeface="Be Vietnam Pro" pitchFamily="34" charset="0"/>
+                <a:ea typeface="Be Vietnam Pro" pitchFamily="34" charset="-122"/>
+                <a:cs typeface="Be Vietnam Pro" pitchFamily="34" charset="-120"/>
+              </a:rPr>
+              <a:t> chức</a:t>
+            </a:r>
+            <a:r>
+              <a:rPr lang="en-US" sz="2250" dirty="0" spc="-1" kern="0">
+                <a:solidFill>
+                  <a:srgbClr val="14161C"/>
+                </a:solidFill>
+                <a:latin typeface="Be Vietnam Pro" pitchFamily="34" charset="0"/>
+                <a:ea typeface="Be Vietnam Pro" pitchFamily="34" charset="-122"/>
+                <a:cs typeface="Be Vietnam Pro" pitchFamily="34" charset="-120"/>
+              </a:rPr>
+              <a:t> năng,</a:t>
+            </a:r>
+            <a:r>
+              <a:rPr lang="en-US" sz="2250" dirty="0" spc="11" kern="0">
+                <a:solidFill>
+                  <a:srgbClr val="14161C"/>
+                </a:solidFill>
+                <a:latin typeface="Be Vietnam Pro" pitchFamily="34" charset="0"/>
+                <a:ea typeface="Be Vietnam Pro" pitchFamily="34" charset="-122"/>
+                <a:cs typeface="Be Vietnam Pro" pitchFamily="34" charset="-120"/>
+              </a:rPr>
+              <a:t> đóng</a:t>
+            </a:r>
+            <a:r>
+              <a:rPr lang="en-US" sz="2250" dirty="0" spc="-11" kern="0">
+                <a:solidFill>
+                  <a:srgbClr val="14161C"/>
+                </a:solidFill>
+                <a:latin typeface="Be Vietnam Pro" pitchFamily="34" charset="0"/>
+                <a:ea typeface="Be Vietnam Pro" pitchFamily="34" charset="-122"/>
+                <a:cs typeface="Be Vietnam Pro" pitchFamily="34" charset="-120"/>
+              </a:rPr>
+              <a:t> gói</a:t>
+            </a:r>
+            <a:r>
+              <a:rPr lang="en-US" sz="2250" dirty="0" spc="0" kern="0">
+                <a:solidFill>
+                  <a:srgbClr val="14161C"/>
+                </a:solidFill>
+                <a:latin typeface="Be Vietnam Pro" pitchFamily="34" charset="0"/>
+                <a:ea typeface="Be Vietnam Pro" pitchFamily="34" charset="-122"/>
+                <a:cs typeface="Be Vietnam Pro" pitchFamily="34" charset="-120"/>
+              </a:rPr>
+              <a:t> thành</a:t>
+            </a:r>
+            <a:r>
+              <a:rPr lang="en-US" sz="2250" dirty="0" spc="25" kern="0">
                 <a:solidFill>
                   <a:srgbClr val="14161C"/>
                 </a:solidFill>
@@ -6044,7 +6110,7 @@
               <a:t> ứng</a:t>
             </a:r>
             <a:r>
-              <a:rPr lang="en-US" sz="2250" dirty="0" spc="3" kern="0">
+              <a:rPr lang="en-US" sz="2250" dirty="0" spc="2" kern="0">
                 <a:solidFill>
                   <a:srgbClr val="14161C"/>
                 </a:solidFill>
@@ -6055,59 +6121,48 @@
               <a:t> dụng</a:t>
             </a:r>
             <a:r>
-              <a:rPr lang="en-US" sz="2250" dirty="0" spc="1" kern="0">
-                <a:solidFill>
-                  <a:srgbClr val="14161C"/>
-                </a:solidFill>
-                <a:latin typeface="Be Vietnam Pro" pitchFamily="34" charset="0"/>
-                <a:ea typeface="Be Vietnam Pro" pitchFamily="34" charset="-122"/>
-                <a:cs typeface="Be Vietnam Pro" pitchFamily="34" charset="-120"/>
-              </a:rPr>
-              <a:t> cho</a:t>
-            </a:r>
-            <a:r>
-              <a:rPr lang="en-US" sz="2250" dirty="0" spc="-5" kern="0">
-                <a:solidFill>
-                  <a:srgbClr val="14161C"/>
-                </a:solidFill>
-                <a:latin typeface="Be Vietnam Pro" pitchFamily="34" charset="0"/>
-                <a:ea typeface="Be Vietnam Pro" pitchFamily="34" charset="-122"/>
-                <a:cs typeface="Be Vietnam Pro" pitchFamily="34" charset="-120"/>
-              </a:rPr>
-              <a:t> thiết</a:t>
-            </a:r>
-            <a:r>
-              <a:rPr lang="en-US" sz="2250" dirty="0" spc="2" kern="0">
-                <a:solidFill>
-                  <a:srgbClr val="14161C"/>
-                </a:solidFill>
-                <a:latin typeface="Be Vietnam Pro" pitchFamily="34" charset="0"/>
-                <a:ea typeface="Be Vietnam Pro" pitchFamily="34" charset="-122"/>
-                <a:cs typeface="Be Vietnam Pro" pitchFamily="34" charset="-120"/>
-              </a:rPr>
-              <a:t> bị</a:t>
-            </a:r>
-            <a:r>
-              <a:rPr lang="en-US" sz="2250" dirty="0" spc="1" kern="0">
-                <a:solidFill>
-                  <a:srgbClr val="14161C"/>
-                </a:solidFill>
-                <a:latin typeface="Be Vietnam Pro" pitchFamily="34" charset="0"/>
-                <a:ea typeface="Be Vietnam Pro" pitchFamily="34" charset="-122"/>
-                <a:cs typeface="Be Vietnam Pro" pitchFamily="34" charset="-120"/>
-              </a:rPr>
-              <a:t> di</a:t>
-            </a:r>
-            <a:r>
-              <a:rPr lang="en-US" sz="2250" dirty="0" spc="10" kern="0">
-                <a:solidFill>
-                  <a:srgbClr val="14161C"/>
-                </a:solidFill>
-                <a:latin typeface="Be Vietnam Pro" pitchFamily="34" charset="0"/>
-                <a:ea typeface="Be Vietnam Pro" pitchFamily="34" charset="-122"/>
-                <a:cs typeface="Be Vietnam Pro" pitchFamily="34" charset="-120"/>
-              </a:rPr>
-              <a:t> động.</a:t>
+              <a:rPr lang="en-US" sz="2250" dirty="0" spc="0" kern="0">
+                <a:solidFill>
+                  <a:srgbClr val="14161C"/>
+                </a:solidFill>
+                <a:latin typeface="Be Vietnam Pro" pitchFamily="34" charset="0"/>
+                <a:ea typeface="Be Vietnam Pro" pitchFamily="34" charset="-122"/>
+                <a:cs typeface="Be Vietnam Pro" pitchFamily="34" charset="-120"/>
+              </a:rPr>
+              <a:t> cài</a:t>
+            </a:r>
+            <a:r>
+              <a:rPr lang="en-US" sz="2250" dirty="0" spc="-19" kern="0">
+                <a:solidFill>
+                  <a:srgbClr val="14161C"/>
+                </a:solidFill>
+                <a:latin typeface="Be Vietnam Pro" pitchFamily="34" charset="0"/>
+                <a:ea typeface="Be Vietnam Pro" pitchFamily="34" charset="-122"/>
+                <a:cs typeface="Be Vietnam Pro" pitchFamily="34" charset="-120"/>
+              </a:rPr>
+              <a:t> trên</a:t>
+            </a:r>
+            <a:r>
+              <a:rPr lang="en-US" sz="2250" dirty="0" spc="18" kern="0">
+                <a:solidFill>
+                  <a:srgbClr val="14161C"/>
+                </a:solidFill>
+                <a:latin typeface="Be Vietnam Pro" pitchFamily="34" charset="0"/>
+                <a:ea typeface="Be Vietnam Pro" pitchFamily="34" charset="-122"/>
+                <a:cs typeface="Be Vietnam Pro" pitchFamily="34" charset="-120"/>
+              </a:rPr>
+              <a:t> điện</a:t>
+            </a:r>
+            <a:r>
+              <a:rPr lang="en-US" sz="2250" dirty="0" spc="-3" kern="0">
+                <a:solidFill>
+                  <a:srgbClr val="14161C"/>
+                </a:solidFill>
+                <a:latin typeface="Be Vietnam Pro" pitchFamily="34" charset="0"/>
+                <a:ea typeface="Be Vietnam Pro" pitchFamily="34" charset="-122"/>
+                <a:cs typeface="Be Vietnam Pro" pitchFamily="34" charset="-120"/>
+              </a:rPr>
+              <a:t> thoại.</a:t>
             </a:r>
             <a:endParaRPr lang="en-US" sz="2250" dirty="0"/>
           </a:p>
@@ -6262,51 +6317,84 @@
               <a:buNone/>
             </a:pPr>
             <a:r>
-              <a:rPr lang="en-US" sz="2250" dirty="0" spc="-7" kern="0">
-                <a:solidFill>
-                  <a:srgbClr val="14161C"/>
-                </a:solidFill>
-                <a:latin typeface="Be Vietnam Pro" pitchFamily="34" charset="0"/>
-                <a:ea typeface="Be Vietnam Pro" pitchFamily="34" charset="-122"/>
-                <a:cs typeface="Be Vietnam Pro" pitchFamily="34" charset="-120"/>
-              </a:rPr>
-              <a:t>Thiết</a:t>
-            </a:r>
-            <a:r>
-              <a:rPr lang="en-US" sz="2250" dirty="0" spc="-34" kern="0">
-                <a:solidFill>
-                  <a:srgbClr val="14161C"/>
-                </a:solidFill>
-                <a:latin typeface="Be Vietnam Pro" pitchFamily="34" charset="0"/>
-                <a:ea typeface="Be Vietnam Pro" pitchFamily="34" charset="-122"/>
-                <a:cs typeface="Be Vietnam Pro" pitchFamily="34" charset="-120"/>
-              </a:rPr>
-              <a:t> kế</a:t>
-            </a:r>
-            <a:r>
-              <a:rPr lang="en-US" sz="2250" dirty="0" spc="-3" kern="0">
-                <a:solidFill>
-                  <a:srgbClr val="14161C"/>
-                </a:solidFill>
-                <a:latin typeface="Be Vietnam Pro" pitchFamily="34" charset="0"/>
-                <a:ea typeface="Be Vietnam Pro" pitchFamily="34" charset="-122"/>
-                <a:cs typeface="Be Vietnam Pro" pitchFamily="34" charset="-120"/>
-              </a:rPr>
-              <a:t> giao</a:t>
-            </a:r>
-            <a:r>
-              <a:rPr lang="en-US" sz="2250" dirty="0" spc="0" kern="0">
-                <a:solidFill>
-                  <a:srgbClr val="14161C"/>
-                </a:solidFill>
-                <a:latin typeface="Be Vietnam Pro" pitchFamily="34" charset="0"/>
-                <a:ea typeface="Be Vietnam Pro" pitchFamily="34" charset="-122"/>
-                <a:cs typeface="Be Vietnam Pro" pitchFamily="34" charset="-120"/>
-              </a:rPr>
-              <a:t> diện</a:t>
-            </a:r>
-            <a:r>
-              <a:rPr lang="en-US" sz="2250" dirty="0" spc="-16" kern="0">
+              <a:rPr lang="en-US" sz="2250" dirty="0" spc="-22" kern="0">
+                <a:solidFill>
+                  <a:srgbClr val="14161C"/>
+                </a:solidFill>
+                <a:latin typeface="Be Vietnam Pro" pitchFamily="34" charset="0"/>
+                <a:ea typeface="Be Vietnam Pro" pitchFamily="34" charset="-122"/>
+                <a:cs typeface="Be Vietnam Pro" pitchFamily="34" charset="-120"/>
+              </a:rPr>
+              <a:t>Quyết</a:t>
+            </a:r>
+            <a:r>
+              <a:rPr lang="en-US" sz="2250" dirty="0" spc="19" kern="0">
+                <a:solidFill>
+                  <a:srgbClr val="14161C"/>
+                </a:solidFill>
+                <a:latin typeface="Be Vietnam Pro" pitchFamily="34" charset="0"/>
+                <a:ea typeface="Be Vietnam Pro" pitchFamily="34" charset="-122"/>
+                <a:cs typeface="Be Vietnam Pro" pitchFamily="34" charset="-120"/>
+              </a:rPr>
+              <a:t> định</a:t>
+            </a:r>
+            <a:r>
+              <a:rPr lang="en-US" sz="2250" dirty="0" spc="1" kern="0">
+                <a:solidFill>
+                  <a:srgbClr val="14161C"/>
+                </a:solidFill>
+                <a:latin typeface="Be Vietnam Pro" pitchFamily="34" charset="0"/>
+                <a:ea typeface="Be Vietnam Pro" pitchFamily="34" charset="-122"/>
+                <a:cs typeface="Be Vietnam Pro" pitchFamily="34" charset="-120"/>
+              </a:rPr>
+              <a:t> bố</a:t>
+            </a:r>
+            <a:r>
+              <a:rPr lang="en-US" sz="2250" dirty="0" spc="3" kern="0">
+                <a:solidFill>
+                  <a:srgbClr val="14161C"/>
+                </a:solidFill>
+                <a:latin typeface="Be Vietnam Pro" pitchFamily="34" charset="0"/>
+                <a:ea typeface="Be Vietnam Pro" pitchFamily="34" charset="-122"/>
+                <a:cs typeface="Be Vietnam Pro" pitchFamily="34" charset="-120"/>
+              </a:rPr>
+              <a:t> cục,</a:t>
+            </a:r>
+            <a:r>
+              <a:rPr lang="en-US" sz="2250" dirty="0" spc="1" kern="0">
+                <a:solidFill>
+                  <a:srgbClr val="14161C"/>
+                </a:solidFill>
+                <a:latin typeface="Be Vietnam Pro" pitchFamily="34" charset="0"/>
+                <a:ea typeface="Be Vietnam Pro" pitchFamily="34" charset="-122"/>
+                <a:cs typeface="Be Vietnam Pro" pitchFamily="34" charset="-120"/>
+              </a:rPr>
+              <a:t> luồng</a:t>
+            </a:r>
+            <a:r>
+              <a:rPr lang="en-US" sz="2250" dirty="0" spc="-2" kern="0">
+                <a:solidFill>
+                  <a:srgbClr val="14161C"/>
+                </a:solidFill>
+                <a:latin typeface="Be Vietnam Pro" pitchFamily="34" charset="0"/>
+                <a:ea typeface="Be Vietnam Pro" pitchFamily="34" charset="-122"/>
+                <a:cs typeface="Be Vietnam Pro" pitchFamily="34" charset="-120"/>
+              </a:rPr>
+              <a:t> thao</a:t>
+            </a:r>
+            <a:r>
+              <a:rPr lang="en-US" sz="2250" dirty="0" spc="-10" kern="0">
+                <a:solidFill>
+                  <a:srgbClr val="14161C"/>
+                </a:solidFill>
+                <a:latin typeface="Be Vietnam Pro" pitchFamily="34" charset="0"/>
+                <a:ea typeface="Be Vietnam Pro" pitchFamily="34" charset="-122"/>
+                <a:cs typeface="Be Vietnam Pro" pitchFamily="34" charset="-120"/>
+              </a:rPr>
+              <a:t> tác</a:t>
+            </a:r>
+            <a:r>
+              <a:rPr lang="en-US" sz="2250" dirty="0" spc="-17" kern="0">
                 <a:solidFill>
                   <a:srgbClr val="14161C"/>
                 </a:solidFill>
@@ -6317,59 +6405,15 @@
               <a:t> và</a:t>
             </a:r>
             <a:r>
-              <a:rPr lang="en-US" sz="2250" dirty="0" spc="-20" kern="0">
-                <a:solidFill>
-                  <a:srgbClr val="14161C"/>
-                </a:solidFill>
-                <a:latin typeface="Be Vietnam Pro" pitchFamily="34" charset="0"/>
-                <a:ea typeface="Be Vietnam Pro" pitchFamily="34" charset="-122"/>
-                <a:cs typeface="Be Vietnam Pro" pitchFamily="34" charset="-120"/>
-              </a:rPr>
-              <a:t> trải</a:t>
-            </a:r>
-            <a:r>
-              <a:rPr lang="en-US" sz="2250" dirty="0" spc="-2" kern="0">
-                <a:solidFill>
-                  <a:srgbClr val="14161C"/>
-                </a:solidFill>
-                <a:latin typeface="Be Vietnam Pro" pitchFamily="34" charset="0"/>
-                <a:ea typeface="Be Vietnam Pro" pitchFamily="34" charset="-122"/>
-                <a:cs typeface="Be Vietnam Pro" pitchFamily="34" charset="-120"/>
-              </a:rPr>
-              <a:t> nghiệm</a:t>
-            </a:r>
-            <a:r>
-              <a:rPr lang="en-US" sz="2250" dirty="0" spc="2" kern="0">
-                <a:solidFill>
-                  <a:srgbClr val="14161C"/>
-                </a:solidFill>
-                <a:latin typeface="Be Vietnam Pro" pitchFamily="34" charset="0"/>
-                <a:ea typeface="Be Vietnam Pro" pitchFamily="34" charset="-122"/>
-                <a:cs typeface="Be Vietnam Pro" pitchFamily="34" charset="-120"/>
-              </a:rPr>
-              <a:t> của</a:t>
-            </a:r>
-            <a:r>
-              <a:rPr lang="en-US" sz="2250" dirty="0" spc="25" kern="0">
-                <a:solidFill>
-                  <a:srgbClr val="14161C"/>
-                </a:solidFill>
-                <a:latin typeface="Be Vietnam Pro" pitchFamily="34" charset="0"/>
-                <a:ea typeface="Be Vietnam Pro" pitchFamily="34" charset="-122"/>
-                <a:cs typeface="Be Vietnam Pro" pitchFamily="34" charset="-120"/>
-              </a:rPr>
-              <a:t> ứng</a:t>
-            </a:r>
-            <a:r>
-              <a:rPr lang="en-US" sz="2250" dirty="0" spc="3" kern="0">
-                <a:solidFill>
-                  <a:srgbClr val="14161C"/>
-                </a:solidFill>
-                <a:latin typeface="Be Vietnam Pro" pitchFamily="34" charset="0"/>
-                <a:ea typeface="Be Vietnam Pro" pitchFamily="34" charset="-122"/>
-                <a:cs typeface="Be Vietnam Pro" pitchFamily="34" charset="-120"/>
-              </a:rPr>
-              <a:t> dụng.</a:t>
+              <a:rPr lang="en-US" sz="2250" dirty="0" spc="7" kern="0">
+                <a:solidFill>
+                  <a:srgbClr val="14161C"/>
+                </a:solidFill>
+                <a:latin typeface="Be Vietnam Pro" pitchFamily="34" charset="0"/>
+                <a:ea typeface="Be Vietnam Pro" pitchFamily="34" charset="-122"/>
+                <a:cs typeface="Be Vietnam Pro" pitchFamily="34" charset="-120"/>
+              </a:rPr>
+              <a:t> độ dễ dùng.</a:t>
             </a:r>
             <a:endParaRPr lang="en-US" sz="2250" dirty="0"/>
           </a:p>
@@ -7267,7 +7311,62 @@
                 <a:ea typeface="Be Vietnam Pro" pitchFamily="34" charset="-122"/>
                 <a:cs typeface="Be Vietnam Pro" pitchFamily="34" charset="-120"/>
               </a:rPr>
-              <a:t> lo</a:t>
+              <a:t> nhận</a:t>
+            </a:r>
+            <a:r>
+              <a:rPr lang="en-US" sz="2550" dirty="0" spc="-21" kern="0">
+                <a:solidFill>
+                  <a:srgbClr val="14161C"/>
+                </a:solidFill>
+                <a:latin typeface="Be Vietnam Pro" pitchFamily="34" charset="0"/>
+                <a:ea typeface="Be Vietnam Pro" pitchFamily="34" charset="-122"/>
+                <a:cs typeface="Be Vietnam Pro" pitchFamily="34" charset="-120"/>
+              </a:rPr>
+              <a:t> yêu</a:t>
+            </a:r>
+            <a:r>
+              <a:rPr lang="en-US" sz="2550" dirty="0" spc="2" kern="0">
+                <a:solidFill>
+                  <a:srgbClr val="14161C"/>
+                </a:solidFill>
+                <a:latin typeface="Be Vietnam Pro" pitchFamily="34" charset="0"/>
+                <a:ea typeface="Be Vietnam Pro" pitchFamily="34" charset="-122"/>
+                <a:cs typeface="Be Vietnam Pro" pitchFamily="34" charset="-120"/>
+              </a:rPr>
+              <a:t> cầu</a:t>
+            </a:r>
+            <a:r>
+              <a:rPr lang="en-US" sz="2550" dirty="0" spc="-18" kern="0">
+                <a:solidFill>
+                  <a:srgbClr val="14161C"/>
+                </a:solidFill>
+                <a:latin typeface="Be Vietnam Pro" pitchFamily="34" charset="0"/>
+                <a:ea typeface="Be Vietnam Pro" pitchFamily="34" charset="-122"/>
+                <a:cs typeface="Be Vietnam Pro" pitchFamily="34" charset="-120"/>
+              </a:rPr>
+              <a:t> và</a:t>
+            </a:r>
+            <a:r>
+              <a:rPr lang="en-US" sz="2550" dirty="0" spc="-24" kern="0">
+                <a:solidFill>
+                  <a:srgbClr val="14161C"/>
+                </a:solidFill>
+                <a:latin typeface="Be Vietnam Pro" pitchFamily="34" charset="0"/>
+                <a:ea typeface="Be Vietnam Pro" pitchFamily="34" charset="-122"/>
+                <a:cs typeface="Be Vietnam Pro" pitchFamily="34" charset="-120"/>
+              </a:rPr>
+              <a:t> trả</a:t>
+            </a:r>
+            <a:r>
+              <a:rPr lang="en-US" sz="2550" dirty="0" spc="-1" kern="0">
+                <a:solidFill>
+                  <a:srgbClr val="14161C"/>
+                </a:solidFill>
+                <a:latin typeface="Be Vietnam Pro" pitchFamily="34" charset="0"/>
+                <a:ea typeface="Be Vietnam Pro" pitchFamily="34" charset="-122"/>
+                <a:cs typeface="Be Vietnam Pro" pitchFamily="34" charset="-120"/>
+              </a:rPr>
+              <a:t> lời;</a:t>
             </a:r>
             <a:r>
               <a:rPr lang="en-US" sz="2550" dirty="0" spc="-2" kern="0">
@@ -7278,7 +7377,40 @@
                 <a:ea typeface="Be Vietnam Pro" pitchFamily="34" charset="-122"/>
                 <a:cs typeface="Be Vietnam Pro" pitchFamily="34" charset="-120"/>
               </a:rPr>
-              <a:t> logic;</a:t>
+              <a:t> cơ sở dữ liệu</a:t>
+            </a:r>
+            <a:r>
+              <a:rPr lang="en-US" sz="2550" dirty="0" spc="-3" kern="0">
+                <a:solidFill>
+                  <a:srgbClr val="14161C"/>
+                </a:solidFill>
+                <a:latin typeface="Be Vietnam Pro" pitchFamily="34" charset="0"/>
+                <a:ea typeface="Be Vietnam Pro" pitchFamily="34" charset="-122"/>
+                <a:cs typeface="Be Vietnam Pro" pitchFamily="34" charset="-120"/>
+              </a:rPr>
+              <a:t> giữ</a:t>
+            </a:r>
+            <a:r>
+              <a:rPr lang="en-US" sz="2550" dirty="0" spc="-2" kern="0">
+                <a:solidFill>
+                  <a:srgbClr val="14161C"/>
+                </a:solidFill>
+                <a:latin typeface="Be Vietnam Pro" pitchFamily="34" charset="0"/>
+                <a:ea typeface="Be Vietnam Pro" pitchFamily="34" charset="-122"/>
+                <a:cs typeface="Be Vietnam Pro" pitchFamily="34" charset="-120"/>
+              </a:rPr>
+              <a:t> dữ</a:t>
+            </a:r>
+            <a:r>
+              <a:rPr lang="en-US" sz="2550" dirty="0" spc="1" kern="0">
+                <a:solidFill>
+                  <a:srgbClr val="14161C"/>
+                </a:solidFill>
+                <a:latin typeface="Be Vietnam Pro" pitchFamily="34" charset="0"/>
+                <a:ea typeface="Be Vietnam Pro" pitchFamily="34" charset="-122"/>
+                <a:cs typeface="Be Vietnam Pro" pitchFamily="34" charset="-120"/>
+              </a:rPr>
+              <a:t> liệu</a:t>
             </a:r>
             <a:r>
               <a:rPr lang="en-US" sz="2550" dirty="0" spc="-1" kern="0">
@@ -7289,106 +7421,7 @@
                 <a:ea typeface="Be Vietnam Pro" pitchFamily="34" charset="-122"/>
                 <a:cs typeface="Be Vietnam Pro" pitchFamily="34" charset="-120"/>
               </a:rPr>
-              <a:t> cơ</a:t>
-            </a:r>
-            <a:r>
-              <a:rPr lang="en-US" sz="2550" dirty="0" spc="-10" kern="0">
-                <a:solidFill>
-                  <a:srgbClr val="14161C"/>
-                </a:solidFill>
-                <a:latin typeface="Be Vietnam Pro" pitchFamily="34" charset="0"/>
-                <a:ea typeface="Be Vietnam Pro" pitchFamily="34" charset="-122"/>
-                <a:cs typeface="Be Vietnam Pro" pitchFamily="34" charset="-120"/>
-              </a:rPr>
-              <a:t> sở</a:t>
-            </a:r>
-            <a:r>
-              <a:rPr lang="en-US" sz="2550" dirty="0" spc="-2" kern="0">
-                <a:solidFill>
-                  <a:srgbClr val="14161C"/>
-                </a:solidFill>
-                <a:latin typeface="Be Vietnam Pro" pitchFamily="34" charset="0"/>
-                <a:ea typeface="Be Vietnam Pro" pitchFamily="34" charset="-122"/>
-                <a:cs typeface="Be Vietnam Pro" pitchFamily="34" charset="-120"/>
-              </a:rPr>
-              <a:t> dữ</a:t>
-            </a:r>
-            <a:r>
-              <a:rPr lang="en-US" sz="2550" dirty="0" spc="1" kern="0">
-                <a:solidFill>
-                  <a:srgbClr val="14161C"/>
-                </a:solidFill>
-                <a:latin typeface="Be Vietnam Pro" pitchFamily="34" charset="0"/>
-                <a:ea typeface="Be Vietnam Pro" pitchFamily="34" charset="-122"/>
-                <a:cs typeface="Be Vietnam Pro" pitchFamily="34" charset="-120"/>
-              </a:rPr>
-              <a:t> liệu</a:t>
-            </a:r>
-            <a:r>
-              <a:rPr lang="en-US" sz="2550" dirty="0" spc="0" kern="0">
-                <a:solidFill>
-                  <a:srgbClr val="14161C"/>
-                </a:solidFill>
-                <a:latin typeface="Be Vietnam Pro" pitchFamily="34" charset="0"/>
-                <a:ea typeface="Be Vietnam Pro" pitchFamily="34" charset="-122"/>
-                <a:cs typeface="Be Vietnam Pro" pitchFamily="34" charset="-120"/>
-              </a:rPr>
-              <a:t> lo</a:t>
-            </a:r>
-            <a:r>
-              <a:rPr lang="en-US" sz="2550" dirty="0" spc="19" kern="0">
-                <a:solidFill>
-                  <a:srgbClr val="14161C"/>
-                </a:solidFill>
-                <a:latin typeface="Be Vietnam Pro" pitchFamily="34" charset="0"/>
-                <a:ea typeface="Be Vietnam Pro" pitchFamily="34" charset="-122"/>
-                <a:cs typeface="Be Vietnam Pro" pitchFamily="34" charset="-120"/>
-              </a:rPr>
-              <a:t> lưu</a:t>
-            </a:r>
-            <a:r>
-              <a:rPr lang="en-US" sz="2550" dirty="0" spc="-1" kern="0">
-                <a:solidFill>
-                  <a:srgbClr val="14161C"/>
-                </a:solidFill>
-                <a:latin typeface="Be Vietnam Pro" pitchFamily="34" charset="0"/>
-                <a:ea typeface="Be Vietnam Pro" pitchFamily="34" charset="-122"/>
-                <a:cs typeface="Be Vietnam Pro" pitchFamily="34" charset="-120"/>
-              </a:rPr>
-              <a:t> trữ</a:t>
-            </a:r>
-            <a:r>
-              <a:rPr lang="en-US" sz="2550" dirty="0" spc="-19" kern="0">
-                <a:solidFill>
-                  <a:srgbClr val="14161C"/>
-                </a:solidFill>
-                <a:latin typeface="Be Vietnam Pro" pitchFamily="34" charset="0"/>
-                <a:ea typeface="Be Vietnam Pro" pitchFamily="34" charset="-122"/>
-                <a:cs typeface="Be Vietnam Pro" pitchFamily="34" charset="-120"/>
-              </a:rPr>
-              <a:t> và</a:t>
-            </a:r>
-            <a:r>
-              <a:rPr lang="en-US" sz="2550" dirty="0" spc="2" kern="0">
-                <a:solidFill>
-                  <a:srgbClr val="14161C"/>
-                </a:solidFill>
-                <a:latin typeface="Be Vietnam Pro" pitchFamily="34" charset="0"/>
-                <a:ea typeface="Be Vietnam Pro" pitchFamily="34" charset="-122"/>
-                <a:cs typeface="Be Vietnam Pro" pitchFamily="34" charset="-120"/>
-              </a:rPr>
-              <a:t> truy</a:t>
-            </a:r>
-            <a:r>
-              <a:rPr lang="en-US" sz="2550" dirty="0" spc="-6" kern="0">
-                <a:solidFill>
-                  <a:srgbClr val="14161C"/>
-                </a:solidFill>
-                <a:latin typeface="Be Vietnam Pro" pitchFamily="34" charset="0"/>
-                <a:ea typeface="Be Vietnam Pro" pitchFamily="34" charset="-122"/>
-                <a:cs typeface="Be Vietnam Pro" pitchFamily="34" charset="-120"/>
-              </a:rPr>
-              <a:t> xuất.</a:t>
+              <a:t> bền.</a:t>
             </a:r>
             <a:endParaRPr lang="en-US" sz="2550" dirty="0"/>
           </a:p>
@@ -7625,15 +7658,26 @@
               <a:buChar char="•"/>
             </a:pPr>
             <a:r>
-              <a:rPr lang="en-US" sz="2250" dirty="0" spc="-22" kern="0">
-                <a:solidFill>
-                  <a:srgbClr val="14161C"/>
-                </a:solidFill>
-                <a:latin typeface="Be Vietnam Pro" pitchFamily="34" charset="0"/>
-                <a:ea typeface="Be Vietnam Pro" pitchFamily="34" charset="-122"/>
-                <a:cs typeface="Be Vietnam Pro" pitchFamily="34" charset="-120"/>
-              </a:rPr>
-              <a:t>Logic</a:t>
+              <a:rPr lang="en-US" sz="2250" dirty="0" spc="-2" kern="0">
+                <a:solidFill>
+                  <a:srgbClr val="14161C"/>
+                </a:solidFill>
+                <a:latin typeface="Be Vietnam Pro" pitchFamily="34" charset="0"/>
+                <a:ea typeface="Be Vietnam Pro" pitchFamily="34" charset="-122"/>
+                <a:cs typeface="Be Vietnam Pro" pitchFamily="34" charset="-120"/>
+              </a:rPr>
+              <a:t>Nhận</a:t>
+            </a:r>
+            <a:r>
+              <a:rPr lang="en-US" sz="2250" dirty="0" spc="-20" kern="0">
+                <a:solidFill>
+                  <a:srgbClr val="14161C"/>
+                </a:solidFill>
+                <a:latin typeface="Be Vietnam Pro" pitchFamily="34" charset="0"/>
+                <a:ea typeface="Be Vietnam Pro" pitchFamily="34" charset="-122"/>
+                <a:cs typeface="Be Vietnam Pro" pitchFamily="34" charset="-120"/>
+              </a:rPr>
+              <a:t> yêu</a:t>
             </a:r>
             <a:r>
               <a:rPr lang="en-US" sz="2250" dirty="0" spc="0" kern="0">
@@ -7644,29 +7688,7 @@
                 <a:ea typeface="Be Vietnam Pro" pitchFamily="34" charset="-122"/>
                 <a:cs typeface="Be Vietnam Pro" pitchFamily="34" charset="-120"/>
               </a:rPr>
-              <a:t> phía</a:t>
-            </a:r>
-            <a:r>
-              <a:rPr lang="en-US" sz="2250" dirty="0" spc="-9" kern="0">
-                <a:solidFill>
-                  <a:srgbClr val="14161C"/>
-                </a:solidFill>
-                <a:latin typeface="Be Vietnam Pro" pitchFamily="34" charset="0"/>
-                <a:ea typeface="Be Vietnam Pro" pitchFamily="34" charset="-122"/>
-                <a:cs typeface="Be Vietnam Pro" pitchFamily="34" charset="-120"/>
-              </a:rPr>
-              <a:t> máy</a:t>
-            </a:r>
-            <a:r>
-              <a:rPr lang="en-US" sz="2250" dirty="0" spc="3" kern="0">
-                <a:solidFill>
-                  <a:srgbClr val="14161C"/>
-                </a:solidFill>
-                <a:latin typeface="Be Vietnam Pro" pitchFamily="34" charset="0"/>
-                <a:ea typeface="Be Vietnam Pro" pitchFamily="34" charset="-122"/>
-                <a:cs typeface="Be Vietnam Pro" pitchFamily="34" charset="-120"/>
-              </a:rPr>
-              <a:t> chủ</a:t>
+              <a:t> cầu</a:t>
             </a:r>
             <a:endParaRPr lang="en-US" sz="2250" dirty="0"/>
           </a:p>
@@ -7738,48 +7760,59 @@
               <a:buChar char="•"/>
             </a:pPr>
             <a:r>
-              <a:rPr lang="en-US" sz="2250" dirty="0" spc="0" kern="0">
-                <a:solidFill>
-                  <a:srgbClr val="14161C"/>
-                </a:solidFill>
-                <a:latin typeface="Be Vietnam Pro" pitchFamily="34" charset="0"/>
-                <a:ea typeface="Be Vietnam Pro" pitchFamily="34" charset="-122"/>
-                <a:cs typeface="Be Vietnam Pro" pitchFamily="34" charset="-120"/>
-              </a:rPr>
-              <a:t>Tích</a:t>
-            </a:r>
-            <a:r>
-              <a:rPr lang="en-US" sz="2250" dirty="0" spc="3" kern="0">
-                <a:solidFill>
-                  <a:srgbClr val="14161C"/>
-                </a:solidFill>
-                <a:latin typeface="Be Vietnam Pro" pitchFamily="34" charset="0"/>
-                <a:ea typeface="Be Vietnam Pro" pitchFamily="34" charset="-122"/>
-                <a:cs typeface="Be Vietnam Pro" pitchFamily="34" charset="-120"/>
-              </a:rPr>
-              <a:t> hợp</a:t>
-            </a:r>
-            <a:r>
-              <a:rPr lang="en-US" sz="2250" dirty="0" spc="-1" kern="0">
-                <a:solidFill>
-                  <a:srgbClr val="14161C"/>
-                </a:solidFill>
-                <a:latin typeface="Be Vietnam Pro" pitchFamily="34" charset="0"/>
-                <a:ea typeface="Be Vietnam Pro" pitchFamily="34" charset="-122"/>
-                <a:cs typeface="Be Vietnam Pro" pitchFamily="34" charset="-120"/>
-              </a:rPr>
-              <a:t> nhiều</a:t>
-            </a:r>
-            <a:r>
-              <a:rPr lang="en-US" sz="2250" dirty="0" spc="2" kern="0">
-                <a:solidFill>
-                  <a:srgbClr val="14161C"/>
-                </a:solidFill>
-                <a:latin typeface="Be Vietnam Pro" pitchFamily="34" charset="0"/>
-                <a:ea typeface="Be Vietnam Pro" pitchFamily="34" charset="-122"/>
-                <a:cs typeface="Be Vietnam Pro" pitchFamily="34" charset="-120"/>
-              </a:rPr>
-              <a:t> dịch vụ</a:t>
+              <a:rPr lang="en-US" sz="2250" dirty="0" spc="-34" kern="0">
+                <a:solidFill>
+                  <a:srgbClr val="14161C"/>
+                </a:solidFill>
+                <a:latin typeface="Be Vietnam Pro" pitchFamily="34" charset="0"/>
+                <a:ea typeface="Be Vietnam Pro" pitchFamily="34" charset="-122"/>
+                <a:cs typeface="Be Vietnam Pro" pitchFamily="34" charset="-120"/>
+              </a:rPr>
+              <a:t>Xử</a:t>
+            </a:r>
+            <a:r>
+              <a:rPr lang="en-US" sz="2250" dirty="0" spc="1" kern="0">
+                <a:solidFill>
+                  <a:srgbClr val="14161C"/>
+                </a:solidFill>
+                <a:latin typeface="Be Vietnam Pro" pitchFamily="34" charset="0"/>
+                <a:ea typeface="Be Vietnam Pro" pitchFamily="34" charset="-122"/>
+                <a:cs typeface="Be Vietnam Pro" pitchFamily="34" charset="-120"/>
+              </a:rPr>
+              <a:t> lý</a:t>
+            </a:r>
+            <a:r>
+              <a:rPr lang="en-US" sz="2250" dirty="0" spc="-23" kern="0">
+                <a:solidFill>
+                  <a:srgbClr val="14161C"/>
+                </a:solidFill>
+                <a:latin typeface="Be Vietnam Pro" pitchFamily="34" charset="0"/>
+                <a:ea typeface="Be Vietnam Pro" pitchFamily="34" charset="-122"/>
+                <a:cs typeface="Be Vietnam Pro" pitchFamily="34" charset="-120"/>
+              </a:rPr>
+              <a:t> rồi</a:t>
+            </a:r>
+            <a:r>
+              <a:rPr lang="en-US" sz="2250" dirty="0" spc="-24" kern="0">
+                <a:solidFill>
+                  <a:srgbClr val="14161C"/>
+                </a:solidFill>
+                <a:latin typeface="Be Vietnam Pro" pitchFamily="34" charset="0"/>
+                <a:ea typeface="Be Vietnam Pro" pitchFamily="34" charset="-122"/>
+                <a:cs typeface="Be Vietnam Pro" pitchFamily="34" charset="-120"/>
+              </a:rPr>
+              <a:t> trả</a:t>
+            </a:r>
+            <a:r>
+              <a:rPr lang="en-US" sz="2250" dirty="0" spc="1" kern="0">
+                <a:solidFill>
+                  <a:srgbClr val="14161C"/>
+                </a:solidFill>
+                <a:latin typeface="Be Vietnam Pro" pitchFamily="34" charset="0"/>
+                <a:ea typeface="Be Vietnam Pro" pitchFamily="34" charset="-122"/>
+                <a:cs typeface="Be Vietnam Pro" pitchFamily="34" charset="-120"/>
+              </a:rPr>
+              <a:t> lời</a:t>
             </a:r>
             <a:endParaRPr lang="en-US" sz="2250" dirty="0"/>
           </a:p>
@@ -7975,18 +8008,7 @@
               <a:t>Lưu</a:t>
             </a:r>
             <a:r>
-              <a:rPr lang="en-US" sz="2250" dirty="0" spc="2" kern="0">
-                <a:solidFill>
-                  <a:srgbClr val="14161C"/>
-                </a:solidFill>
-                <a:latin typeface="Be Vietnam Pro" pitchFamily="34" charset="0"/>
-                <a:ea typeface="Be Vietnam Pro" pitchFamily="34" charset="-122"/>
-                <a:cs typeface="Be Vietnam Pro" pitchFamily="34" charset="-120"/>
-              </a:rPr>
-              <a:t> trữ</a:t>
-            </a:r>
-            <a:r>
-              <a:rPr lang="en-US" sz="2250" dirty="0" spc="4" kern="0">
+              <a:rPr lang="en-US" sz="2250" dirty="0" spc="5" kern="0">
                 <a:solidFill>
                   <a:srgbClr val="14161C"/>
                 </a:solidFill>
@@ -8006,6 +8028,39 @@
                 <a:cs typeface="Be Vietnam Pro" pitchFamily="34" charset="-120"/>
               </a:rPr>
               <a:t> liệu</a:t>
+            </a:r>
+            <a:r>
+              <a:rPr lang="en-US" sz="2250" dirty="0" spc="5" kern="0">
+                <a:solidFill>
+                  <a:srgbClr val="14161C"/>
+                </a:solidFill>
+                <a:latin typeface="Be Vietnam Pro" pitchFamily="34" charset="0"/>
+                <a:ea typeface="Be Vietnam Pro" pitchFamily="34" charset="-122"/>
+                <a:cs typeface="Be Vietnam Pro" pitchFamily="34" charset="-120"/>
+              </a:rPr>
+              <a:t> có</a:t>
+            </a:r>
+            <a:r>
+              <a:rPr lang="en-US" sz="2250" dirty="0" spc="-11" kern="0">
+                <a:solidFill>
+                  <a:srgbClr val="14161C"/>
+                </a:solidFill>
+                <a:latin typeface="Be Vietnam Pro" pitchFamily="34" charset="0"/>
+                <a:ea typeface="Be Vietnam Pro" pitchFamily="34" charset="-122"/>
+                <a:cs typeface="Be Vietnam Pro" pitchFamily="34" charset="-120"/>
+              </a:rPr>
+              <a:t> tổ</a:t>
+            </a:r>
+            <a:r>
+              <a:rPr lang="en-US" sz="2250" dirty="0" spc="10" kern="0">
+                <a:solidFill>
+                  <a:srgbClr val="14161C"/>
+                </a:solidFill>
+                <a:latin typeface="Be Vietnam Pro" pitchFamily="34" charset="0"/>
+                <a:ea typeface="Be Vietnam Pro" pitchFamily="34" charset="-122"/>
+                <a:cs typeface="Be Vietnam Pro" pitchFamily="34" charset="-120"/>
+              </a:rPr>
+              <a:t> chức</a:t>
             </a:r>
             <a:endParaRPr lang="en-US" sz="2250" dirty="0"/>
           </a:p>
@@ -8022,48 +8077,15 @@
               <a:buChar char="•"/>
             </a:pPr>
             <a:r>
-              <a:rPr lang="en-US" sz="2250" dirty="0" spc="-41" kern="0">
-                <a:solidFill>
-                  <a:srgbClr val="14161C"/>
-                </a:solidFill>
-                <a:latin typeface="Be Vietnam Pro" pitchFamily="34" charset="0"/>
-                <a:ea typeface="Be Vietnam Pro" pitchFamily="34" charset="-122"/>
-                <a:cs typeface="Be Vietnam Pro" pitchFamily="34" charset="-120"/>
-              </a:rPr>
-              <a:t>Truy</a:t>
-            </a:r>
-            <a:r>
-              <a:rPr lang="en-US" sz="2250" dirty="0" spc="-11" kern="0">
-                <a:solidFill>
-                  <a:srgbClr val="14161C"/>
-                </a:solidFill>
-                <a:latin typeface="Be Vietnam Pro" pitchFamily="34" charset="0"/>
-                <a:ea typeface="Be Vietnam Pro" pitchFamily="34" charset="-122"/>
-                <a:cs typeface="Be Vietnam Pro" pitchFamily="34" charset="-120"/>
-              </a:rPr>
-              <a:t> xuất</a:t>
-            </a:r>
-            <a:r>
-              <a:rPr lang="en-US" sz="2250" dirty="0" spc="5" kern="0">
-                <a:solidFill>
-                  <a:srgbClr val="14161C"/>
-                </a:solidFill>
-                <a:latin typeface="Be Vietnam Pro" pitchFamily="34" charset="0"/>
-                <a:ea typeface="Be Vietnam Pro" pitchFamily="34" charset="-122"/>
-                <a:cs typeface="Be Vietnam Pro" pitchFamily="34" charset="-120"/>
-              </a:rPr>
-              <a:t> dữ</a:t>
-            </a:r>
-            <a:r>
-              <a:rPr lang="en-US" sz="2250" dirty="0" spc="-1" kern="0">
-                <a:solidFill>
-                  <a:srgbClr val="14161C"/>
-                </a:solidFill>
-                <a:latin typeface="Be Vietnam Pro" pitchFamily="34" charset="0"/>
-                <a:ea typeface="Be Vietnam Pro" pitchFamily="34" charset="-122"/>
-                <a:cs typeface="Be Vietnam Pro" pitchFamily="34" charset="-120"/>
-              </a:rPr>
-              <a:t> liệu</a:t>
+              <a:rPr lang="en-US" sz="2250" dirty="0" spc="-2" kern="0">
+                <a:solidFill>
+                  <a:srgbClr val="14161C"/>
+                </a:solidFill>
+                <a:latin typeface="Be Vietnam Pro" pitchFamily="34" charset="0"/>
+                <a:ea typeface="Be Vietnam Pro" pitchFamily="34" charset="-122"/>
+                <a:cs typeface="Be Vietnam Pro" pitchFamily="34" charset="-120"/>
+              </a:rPr>
+              <a:t>Tìm</a:t>
             </a:r>
             <a:endParaRPr lang="en-US" sz="2250" dirty="0"/>
           </a:p>
@@ -8077,48 +8099,26 @@
               <a:buChar char="•"/>
             </a:pPr>
             <a:r>
-              <a:rPr lang="en-US" sz="2250" dirty="0" spc="-34" kern="0">
-                <a:solidFill>
-                  <a:srgbClr val="14161C"/>
-                </a:solidFill>
-                <a:latin typeface="Be Vietnam Pro" pitchFamily="34" charset="0"/>
-                <a:ea typeface="Be Vietnam Pro" pitchFamily="34" charset="-122"/>
-                <a:cs typeface="Be Vietnam Pro" pitchFamily="34" charset="-120"/>
-              </a:rPr>
-              <a:t>Xử</a:t>
-            </a:r>
-            <a:r>
-              <a:rPr lang="en-US" sz="2250" dirty="0" spc="1" kern="0">
-                <a:solidFill>
-                  <a:srgbClr val="14161C"/>
-                </a:solidFill>
-                <a:latin typeface="Be Vietnam Pro" pitchFamily="34" charset="0"/>
-                <a:ea typeface="Be Vietnam Pro" pitchFamily="34" charset="-122"/>
-                <a:cs typeface="Be Vietnam Pro" pitchFamily="34" charset="-120"/>
-              </a:rPr>
-              <a:t> lý</a:t>
-            </a:r>
-            <a:r>
-              <a:rPr lang="en-US" sz="2250" dirty="0" spc="5" kern="0">
-                <a:solidFill>
-                  <a:srgbClr val="14161C"/>
-                </a:solidFill>
-                <a:latin typeface="Be Vietnam Pro" pitchFamily="34" charset="0"/>
-                <a:ea typeface="Be Vietnam Pro" pitchFamily="34" charset="-122"/>
-                <a:cs typeface="Be Vietnam Pro" pitchFamily="34" charset="-120"/>
-              </a:rPr>
-              <a:t> dữ</a:t>
-            </a:r>
-            <a:r>
-              <a:rPr lang="en-US" sz="2250" dirty="0" spc="-2" kern="0">
-                <a:solidFill>
-                  <a:srgbClr val="14161C"/>
-                </a:solidFill>
-                <a:latin typeface="Be Vietnam Pro" pitchFamily="34" charset="0"/>
-                <a:ea typeface="Be Vietnam Pro" pitchFamily="34" charset="-122"/>
-                <a:cs typeface="Be Vietnam Pro" pitchFamily="34" charset="-120"/>
-              </a:rPr>
-              <a:t> liệu</a:t>
+              <a:rPr lang="en-US" sz="2250" dirty="0" spc="-1" kern="0">
+                <a:solidFill>
+                  <a:srgbClr val="14161C"/>
+                </a:solidFill>
+                <a:latin typeface="Be Vietnam Pro" pitchFamily="34" charset="0"/>
+                <a:ea typeface="Be Vietnam Pro" pitchFamily="34" charset="-122"/>
+                <a:cs typeface="Be Vietnam Pro" pitchFamily="34" charset="-120"/>
+              </a:rPr>
+              <a:t>Mở</a:t>
+            </a:r>
+            <a:r>
+              <a:rPr lang="en-US" sz="2250" dirty="0" spc="-17" kern="0">
+                <a:solidFill>
+                  <a:srgbClr val="14161C"/>
+                </a:solidFill>
+                <a:latin typeface="Be Vietnam Pro" pitchFamily="34" charset="0"/>
+                <a:ea typeface="Be Vietnam Pro" pitchFamily="34" charset="-122"/>
+                <a:cs typeface="Be Vietnam Pro" pitchFamily="34" charset="-120"/>
+              </a:rPr>
+              <a:t> rộng</a:t>
             </a:r>
             <a:endParaRPr lang="en-US" sz="2250" dirty="0"/>
           </a:p>
@@ -9496,17 +9496,6 @@
               <a:buNone/>
             </a:pPr>
             <a:r>
-              <a:rPr lang="en-US" sz="2250" dirty="0" spc="-25" kern="0">
-                <a:solidFill>
-                  <a:srgbClr val="14161C"/>
-                </a:solidFill>
-                <a:latin typeface="Be Vietnam Pro" pitchFamily="34" charset="0"/>
-                <a:ea typeface="Be Vietnam Pro" pitchFamily="34" charset="-122"/>
-                <a:cs typeface="Be Vietnam Pro" pitchFamily="34" charset="-120"/>
-              </a:rPr>
-              <a:t>Triển</a:t>
-            </a:r>
-            <a:r>
               <a:rPr lang="en-US" sz="2250" dirty="0" spc="-2" kern="0">
                 <a:solidFill>
                   <a:srgbClr val="14161C"/>
@@ -9515,7 +9504,18 @@
                 <a:ea typeface="Be Vietnam Pro" pitchFamily="34" charset="-122"/>
                 <a:cs typeface="Be Vietnam Pro" pitchFamily="34" charset="-120"/>
               </a:rPr>
-              <a:t> khai</a:t>
+              <a:t>Thuê</a:t>
+            </a:r>
+            <a:r>
+              <a:rPr lang="en-US" sz="2250" dirty="0" spc="-9" kern="0">
+                <a:solidFill>
+                  <a:srgbClr val="14161C"/>
+                </a:solidFill>
+                <a:latin typeface="Be Vietnam Pro" pitchFamily="34" charset="0"/>
+                <a:ea typeface="Be Vietnam Pro" pitchFamily="34" charset="-122"/>
+                <a:cs typeface="Be Vietnam Pro" pitchFamily="34" charset="-120"/>
+              </a:rPr>
+              <a:t> máy</a:t>
             </a:r>
             <a:r>
               <a:rPr lang="en-US" sz="2250" dirty="0" spc="-17" kern="0">
@@ -9529,6 +9529,17 @@
               <a:t> và</a:t>
             </a:r>
             <a:r>
+              <a:rPr lang="en-US" sz="2250" dirty="0" spc="2" kern="0">
+                <a:solidFill>
+                  <a:srgbClr val="14161C"/>
+                </a:solidFill>
+                <a:latin typeface="Be Vietnam Pro" pitchFamily="34" charset="0"/>
+                <a:ea typeface="Be Vietnam Pro" pitchFamily="34" charset="-122"/>
+                <a:cs typeface="Be Vietnam Pro" pitchFamily="34" charset="-120"/>
+              </a:rPr>
+              <a:t> dịch</a:t>
+            </a:r>
+            <a:r>
               <a:rPr lang="en-US" sz="2250" dirty="0" spc="1" kern="0">
                 <a:solidFill>
                   <a:srgbClr val="14161C"/>
@@ -9537,7 +9548,29 @@
                 <a:ea typeface="Be Vietnam Pro" pitchFamily="34" charset="-122"/>
                 <a:cs typeface="Be Vietnam Pro" pitchFamily="34" charset="-120"/>
               </a:rPr>
-              <a:t> quản lý</a:t>
+              <a:t> vụ</a:t>
+            </a:r>
+            <a:r>
+              <a:rPr lang="en-US" sz="2250" dirty="0" spc="16" kern="0">
+                <a:solidFill>
+                  <a:srgbClr val="14161C"/>
+                </a:solidFill>
+                <a:latin typeface="Be Vietnam Pro" pitchFamily="34" charset="0"/>
+                <a:ea typeface="Be Vietnam Pro" pitchFamily="34" charset="-122"/>
+                <a:cs typeface="Be Vietnam Pro" pitchFamily="34" charset="-120"/>
+              </a:rPr>
+              <a:t> để</a:t>
+            </a:r>
+            <a:r>
+              <a:rPr lang="en-US" sz="2250" dirty="0" spc="-6" kern="0">
+                <a:solidFill>
+                  <a:srgbClr val="14161C"/>
+                </a:solidFill>
+                <a:latin typeface="Be Vietnam Pro" pitchFamily="34" charset="0"/>
+                <a:ea typeface="Be Vietnam Pro" pitchFamily="34" charset="-122"/>
+                <a:cs typeface="Be Vietnam Pro" pitchFamily="34" charset="-120"/>
+              </a:rPr>
+              <a:t> chạy</a:t>
             </a:r>
             <a:r>
               <a:rPr lang="en-US" sz="2250" dirty="0" spc="24" kern="0">
@@ -9559,62 +9592,7 @@
                 <a:ea typeface="Be Vietnam Pro" pitchFamily="34" charset="-122"/>
                 <a:cs typeface="Be Vietnam Pro" pitchFamily="34" charset="-120"/>
               </a:rPr>
-              <a:t> dụng</a:t>
-            </a:r>
-            <a:r>
-              <a:rPr lang="en-US" sz="2250" dirty="0" spc="-19" kern="0">
-                <a:solidFill>
-                  <a:srgbClr val="14161C"/>
-                </a:solidFill>
-                <a:latin typeface="Be Vietnam Pro" pitchFamily="34" charset="0"/>
-                <a:ea typeface="Be Vietnam Pro" pitchFamily="34" charset="-122"/>
-                <a:cs typeface="Be Vietnam Pro" pitchFamily="34" charset="-120"/>
-              </a:rPr>
-              <a:t> trên</a:t>
-            </a:r>
-            <a:r>
-              <a:rPr lang="en-US" sz="2250" dirty="0" spc="1" kern="0">
-                <a:solidFill>
-                  <a:srgbClr val="14161C"/>
-                </a:solidFill>
-                <a:latin typeface="Be Vietnam Pro" pitchFamily="34" charset="0"/>
-                <a:ea typeface="Be Vietnam Pro" pitchFamily="34" charset="-122"/>
-                <a:cs typeface="Be Vietnam Pro" pitchFamily="34" charset="-120"/>
-              </a:rPr>
-              <a:t> nền</a:t>
-            </a:r>
-            <a:r>
-              <a:rPr lang="en-US" sz="2250" dirty="0" spc="-9" kern="0">
-                <a:solidFill>
-                  <a:srgbClr val="14161C"/>
-                </a:solidFill>
-                <a:latin typeface="Be Vietnam Pro" pitchFamily="34" charset="0"/>
-                <a:ea typeface="Be Vietnam Pro" pitchFamily="34" charset="-122"/>
-                <a:cs typeface="Be Vietnam Pro" pitchFamily="34" charset="-120"/>
-              </a:rPr>
-              <a:t> tảng</a:t>
-            </a:r>
-            <a:r>
-              <a:rPr lang="en-US" sz="2250" dirty="0" spc="11" kern="0">
-                <a:solidFill>
-                  <a:srgbClr val="14161C"/>
-                </a:solidFill>
-                <a:latin typeface="Be Vietnam Pro" pitchFamily="34" charset="0"/>
-                <a:ea typeface="Be Vietnam Pro" pitchFamily="34" charset="-122"/>
-                <a:cs typeface="Be Vietnam Pro" pitchFamily="34" charset="-120"/>
-              </a:rPr>
-              <a:t> đám</a:t>
-            </a:r>
-            <a:r>
-              <a:rPr lang="en-US" sz="2250" dirty="0" spc="-7" kern="0">
-                <a:solidFill>
-                  <a:srgbClr val="14161C"/>
-                </a:solidFill>
-                <a:latin typeface="Be Vietnam Pro" pitchFamily="34" charset="0"/>
-                <a:ea typeface="Be Vietnam Pro" pitchFamily="34" charset="-122"/>
-                <a:cs typeface="Be Vietnam Pro" pitchFamily="34" charset="-120"/>
-              </a:rPr>
-              <a:t> mây.</a:t>
+              <a:t> dụng.</a:t>
             </a:r>
             <a:endParaRPr lang="en-US" sz="2250" dirty="0"/>
           </a:p>
@@ -9769,15 +9747,26 @@
               <a:buNone/>
             </a:pPr>
             <a:r>
-              <a:rPr lang="en-US" sz="2250" dirty="0" spc="-2" kern="0">
-                <a:solidFill>
-                  <a:srgbClr val="14161C"/>
-                </a:solidFill>
-                <a:latin typeface="Be Vietnam Pro" pitchFamily="34" charset="0"/>
-                <a:ea typeface="Be Vietnam Pro" pitchFamily="34" charset="-122"/>
-                <a:cs typeface="Be Vietnam Pro" pitchFamily="34" charset="-120"/>
-              </a:rPr>
-              <a:t>Quản</a:t>
+              <a:rPr lang="en-US" sz="2250" dirty="0" spc="-1" kern="0">
+                <a:solidFill>
+                  <a:srgbClr val="14161C"/>
+                </a:solidFill>
+                <a:latin typeface="Be Vietnam Pro" pitchFamily="34" charset="0"/>
+                <a:ea typeface="Be Vietnam Pro" pitchFamily="34" charset="-122"/>
+                <a:cs typeface="Be Vietnam Pro" pitchFamily="34" charset="-120"/>
+              </a:rPr>
+              <a:t>Giữ</a:t>
+            </a:r>
+            <a:r>
+              <a:rPr lang="en-US" sz="2250" dirty="0" spc="25" kern="0">
+                <a:solidFill>
+                  <a:srgbClr val="14161C"/>
+                </a:solidFill>
+                <a:latin typeface="Be Vietnam Pro" pitchFamily="34" charset="0"/>
+                <a:ea typeface="Be Vietnam Pro" pitchFamily="34" charset="-122"/>
+                <a:cs typeface="Be Vietnam Pro" pitchFamily="34" charset="-120"/>
+              </a:rPr>
+              <a:t> ứng</a:t>
             </a:r>
             <a:r>
               <a:rPr lang="en-US" sz="2250" dirty="0" spc="2" kern="0">
@@ -9788,7 +9777,40 @@
                 <a:ea typeface="Be Vietnam Pro" pitchFamily="34" charset="-122"/>
                 <a:cs typeface="Be Vietnam Pro" pitchFamily="34" charset="-120"/>
               </a:rPr>
-              <a:t> lý</a:t>
+              <a:t> dụng</a:t>
+            </a:r>
+            <a:r>
+              <a:rPr lang="en-US" sz="2250" dirty="0" spc="-6" kern="0">
+                <a:solidFill>
+                  <a:srgbClr val="14161C"/>
+                </a:solidFill>
+                <a:latin typeface="Be Vietnam Pro" pitchFamily="34" charset="0"/>
+                <a:ea typeface="Be Vietnam Pro" pitchFamily="34" charset="-122"/>
+                <a:cs typeface="Be Vietnam Pro" pitchFamily="34" charset="-120"/>
+              </a:rPr>
+              <a:t> chạy</a:t>
+            </a:r>
+            <a:r>
+              <a:rPr lang="en-US" sz="2250" dirty="0" spc="-17" kern="0">
+                <a:solidFill>
+                  <a:srgbClr val="14161C"/>
+                </a:solidFill>
+                <a:latin typeface="Be Vietnam Pro" pitchFamily="34" charset="0"/>
+                <a:ea typeface="Be Vietnam Pro" pitchFamily="34" charset="-122"/>
+                <a:cs typeface="Be Vietnam Pro" pitchFamily="34" charset="-120"/>
+              </a:rPr>
+              <a:t> và</a:t>
+            </a:r>
+            <a:r>
+              <a:rPr lang="en-US" sz="2250" dirty="0" spc="8" kern="0">
+                <a:solidFill>
+                  <a:srgbClr val="14161C"/>
+                </a:solidFill>
+                <a:latin typeface="Be Vietnam Pro" pitchFamily="34" charset="0"/>
+                <a:ea typeface="Be Vietnam Pro" pitchFamily="34" charset="-122"/>
+                <a:cs typeface="Be Vietnam Pro" pitchFamily="34" charset="-120"/>
+              </a:rPr>
+              <a:t> đưa</a:t>
             </a:r>
             <a:r>
               <a:rPr lang="en-US" sz="2250" dirty="0" spc="-1" kern="0">
@@ -9799,51 +9821,7 @@
                 <a:ea typeface="Be Vietnam Pro" pitchFamily="34" charset="-122"/>
                 <a:cs typeface="Be Vietnam Pro" pitchFamily="34" charset="-120"/>
               </a:rPr>
-              <a:t> hạ</a:t>
-            </a:r>
-            <a:r>
-              <a:rPr lang="en-US" sz="2250" dirty="0" spc="-9" kern="0">
-                <a:solidFill>
-                  <a:srgbClr val="14161C"/>
-                </a:solidFill>
-                <a:latin typeface="Be Vietnam Pro" pitchFamily="34" charset="0"/>
-                <a:ea typeface="Be Vietnam Pro" pitchFamily="34" charset="-122"/>
-                <a:cs typeface="Be Vietnam Pro" pitchFamily="34" charset="-120"/>
-              </a:rPr>
-              <a:t> tầng,</a:t>
-            </a:r>
-            <a:r>
-              <a:rPr lang="en-US" sz="2250" dirty="0" spc="6" kern="0">
-                <a:solidFill>
-                  <a:srgbClr val="14161C"/>
-                </a:solidFill>
-                <a:latin typeface="Be Vietnam Pro" pitchFamily="34" charset="0"/>
-                <a:ea typeface="Be Vietnam Pro" pitchFamily="34" charset="-122"/>
-                <a:cs typeface="Be Vietnam Pro" pitchFamily="34" charset="-120"/>
-              </a:rPr>
-              <a:t> triển</a:t>
-            </a:r>
-            <a:r>
-              <a:rPr lang="en-US" sz="2250" dirty="0" spc="-1" kern="0">
-                <a:solidFill>
-                  <a:srgbClr val="14161C"/>
-                </a:solidFill>
-                <a:latin typeface="Be Vietnam Pro" pitchFamily="34" charset="0"/>
-                <a:ea typeface="Be Vietnam Pro" pitchFamily="34" charset="-122"/>
-                <a:cs typeface="Be Vietnam Pro" pitchFamily="34" charset="-120"/>
-              </a:rPr>
-              <a:t> khai</a:t>
-            </a:r>
-            <a:r>
-              <a:rPr lang="en-US" sz="2250" dirty="0" spc="-17" kern="0">
-                <a:solidFill>
-                  <a:srgbClr val="14161C"/>
-                </a:solidFill>
-                <a:latin typeface="Be Vietnam Pro" pitchFamily="34" charset="0"/>
-                <a:ea typeface="Be Vietnam Pro" pitchFamily="34" charset="-122"/>
-                <a:cs typeface="Be Vietnam Pro" pitchFamily="34" charset="-120"/>
-              </a:rPr>
-              <a:t> và</a:t>
+              <a:t> bản</a:t>
             </a:r>
             <a:r>
               <a:rPr lang="en-US" sz="2250" dirty="0" spc="0" kern="0">
@@ -9854,7 +9832,7 @@
                 <a:ea typeface="Be Vietnam Pro" pitchFamily="34" charset="-122"/>
                 <a:cs typeface="Be Vietnam Pro" pitchFamily="34" charset="-120"/>
               </a:rPr>
-              <a:t> CI/CD.</a:t>
+              <a:t> mới lên qua CI/CD.</a:t>
             </a:r>
             <a:endParaRPr lang="en-US" sz="2250" dirty="0"/>
           </a:p>
@@ -18863,7 +18841,7 @@
         </p:nvSpPr>
         <p:spPr>
           <a:xfrm>
-            <a:off x="1295400" y="6877050"/>
+            <a:off x="1295400" y="6800850"/>
             <a:ext cx="7620000" cy="285750"/>
           </a:xfrm>
           <a:prstGeom prst="rect">
@@ -18913,7 +18891,7 @@
         </p:nvSpPr>
         <p:spPr>
           <a:xfrm>
-            <a:off x="1295400" y="7315200"/>
+            <a:off x="1295400" y="7162800"/>
             <a:ext cx="15697200" cy="495300"/>
           </a:xfrm>
           <a:prstGeom prst="rect">
@@ -19040,7 +19018,7 @@
         </p:nvSpPr>
         <p:spPr>
           <a:xfrm>
-            <a:off x="1295400" y="7962900"/>
+            <a:off x="1295400" y="7696200"/>
             <a:ext cx="15697200" cy="419100"/>
           </a:xfrm>
           <a:prstGeom prst="rect">
@@ -19524,7 +19502,200 @@
       </p:sp>
       <p:sp>
         <p:nvSpPr>
-          <p:cNvPr id="34" name="Shape 32"/>
+          <p:cNvPr id="34" name="Text 32"/>
+          <p:cNvSpPr/>
+          <p:nvPr/>
+        </p:nvSpPr>
+        <p:spPr>
+          <a:xfrm>
+            <a:off x="1295400" y="8153400"/>
+            <a:ext cx="15697200" cy="419100"/>
+          </a:xfrm>
+          <a:prstGeom prst="rect">
+            <a:avLst/>
+          </a:prstGeom>
+          <a:noFill/>
+          <a:ln/>
+        </p:spPr>
+        <p:txBody>
+          <a:bodyPr wrap="square" lIns="0" tIns="0" rIns="0" bIns="0" rtlCol="0" anchor="ctr"/>
+          <a:lstStyle/>
+          <a:p>
+            <a:pPr algn="l" indent="0" marL="0">
+              <a:buNone/>
+            </a:pPr>
+            <a:r>
+              <a:rPr lang="en-US" sz="2250" dirty="0" spc="-29" kern="0">
+                <a:solidFill>
+                  <a:srgbClr val="C4C8D6"/>
+                </a:solidFill>
+                <a:latin typeface="Be Vietnam Pro" pitchFamily="34" charset="0"/>
+                <a:ea typeface="Be Vietnam Pro" pitchFamily="34" charset="-122"/>
+                <a:cs typeface="Be Vietnam Pro" pitchFamily="34" charset="-120"/>
+              </a:rPr>
+              <a:t>Lời</a:t>
+            </a:r>
+            <a:r>
+              <a:rPr lang="en-US" sz="2250" dirty="0" spc="-3" kern="0">
+                <a:solidFill>
+                  <a:srgbClr val="C4C8D6"/>
+                </a:solidFill>
+                <a:latin typeface="Be Vietnam Pro" pitchFamily="34" charset="0"/>
+                <a:ea typeface="Be Vietnam Pro" pitchFamily="34" charset="-122"/>
+                <a:cs typeface="Be Vietnam Pro" pitchFamily="34" charset="-120"/>
+              </a:rPr>
+              <a:t> giải</a:t>
+            </a:r>
+            <a:r>
+              <a:rPr lang="en-US" sz="2250" dirty="0" spc="0" kern="0">
+                <a:solidFill>
+                  <a:srgbClr val="C4C8D6"/>
+                </a:solidFill>
+                <a:latin typeface="Be Vietnam Pro" pitchFamily="34" charset="0"/>
+                <a:ea typeface="Be Vietnam Pro" pitchFamily="34" charset="-122"/>
+                <a:cs typeface="Be Vietnam Pro" pitchFamily="34" charset="-120"/>
+              </a:rPr>
+              <a:t> thích</a:t>
+            </a:r>
+            <a:r>
+              <a:rPr lang="en-US" sz="2250" dirty="0" spc="20" kern="0">
+                <a:solidFill>
+                  <a:srgbClr val="C4C8D6"/>
+                </a:solidFill>
+                <a:latin typeface="Be Vietnam Pro" pitchFamily="34" charset="0"/>
+                <a:ea typeface="Be Vietnam Pro" pitchFamily="34" charset="-122"/>
+                <a:cs typeface="Be Vietnam Pro" pitchFamily="34" charset="-120"/>
+              </a:rPr>
+              <a:t> từng</a:t>
+            </a:r>
+            <a:r>
+              <a:rPr lang="en-US" sz="2250" dirty="0" spc="1" kern="0">
+                <a:solidFill>
+                  <a:srgbClr val="C4C8D6"/>
+                </a:solidFill>
+                <a:latin typeface="Be Vietnam Pro" pitchFamily="34" charset="0"/>
+                <a:ea typeface="Be Vietnam Pro" pitchFamily="34" charset="-122"/>
+                <a:cs typeface="Be Vietnam Pro" pitchFamily="34" charset="-120"/>
+              </a:rPr>
+              <a:t> vùng</a:t>
+            </a:r>
+            <a:r>
+              <a:rPr lang="en-US" sz="2250" dirty="0" spc="0" kern="0">
+                <a:solidFill>
+                  <a:srgbClr val="C4C8D6"/>
+                </a:solidFill>
+                <a:latin typeface="Be Vietnam Pro" pitchFamily="34" charset="0"/>
+                <a:ea typeface="Be Vietnam Pro" pitchFamily="34" charset="-122"/>
+                <a:cs typeface="Be Vietnam Pro" pitchFamily="34" charset="-120"/>
+              </a:rPr>
+              <a:t> là</a:t>
+            </a:r>
+            <a:r>
+              <a:rPr lang="en-US" sz="2250" dirty="0" spc="2" kern="0">
+                <a:solidFill>
+                  <a:srgbClr val="C4C8D6"/>
+                </a:solidFill>
+                <a:latin typeface="Be Vietnam Pro" pitchFamily="34" charset="0"/>
+                <a:ea typeface="Be Vietnam Pro" pitchFamily="34" charset="-122"/>
+                <a:cs typeface="Be Vietnam Pro" pitchFamily="34" charset="-120"/>
+              </a:rPr>
+              <a:t> của</a:t>
+            </a:r>
+            <a:r>
+              <a:rPr lang="en-US" sz="2250" dirty="0" spc="5" kern="0">
+                <a:solidFill>
+                  <a:srgbClr val="C4C8D6"/>
+                </a:solidFill>
+                <a:latin typeface="Be Vietnam Pro" pitchFamily="34" charset="0"/>
+                <a:ea typeface="Be Vietnam Pro" pitchFamily="34" charset="-122"/>
+                <a:cs typeface="Be Vietnam Pro" pitchFamily="34" charset="-120"/>
+              </a:rPr>
+              <a:t> người</a:t>
+            </a:r>
+            <a:r>
+              <a:rPr lang="en-US" sz="2250" dirty="0" spc="0" kern="0">
+                <a:solidFill>
+                  <a:srgbClr val="C4C8D6"/>
+                </a:solidFill>
+                <a:latin typeface="Be Vietnam Pro" pitchFamily="34" charset="0"/>
+                <a:ea typeface="Be Vietnam Pro" pitchFamily="34" charset="-122"/>
+                <a:cs typeface="Be Vietnam Pro" pitchFamily="34" charset="-120"/>
+              </a:rPr>
+              <a:t> biên</a:t>
+            </a:r>
+            <a:r>
+              <a:rPr lang="en-US" sz="2250" dirty="0" spc="-6" kern="0">
+                <a:solidFill>
+                  <a:srgbClr val="C4C8D6"/>
+                </a:solidFill>
+                <a:latin typeface="Be Vietnam Pro" pitchFamily="34" charset="0"/>
+                <a:ea typeface="Be Vietnam Pro" pitchFamily="34" charset="-122"/>
+                <a:cs typeface="Be Vietnam Pro" pitchFamily="34" charset="-120"/>
+              </a:rPr>
+              <a:t> soạn,</a:t>
+            </a:r>
+            <a:r>
+              <a:rPr lang="en-US" sz="2250" dirty="0" spc="1" kern="0">
+                <a:solidFill>
+                  <a:srgbClr val="C4C8D6"/>
+                </a:solidFill>
+                <a:latin typeface="Be Vietnam Pro" pitchFamily="34" charset="0"/>
+                <a:ea typeface="Be Vietnam Pro" pitchFamily="34" charset="-122"/>
+                <a:cs typeface="Be Vietnam Pro" pitchFamily="34" charset="-120"/>
+              </a:rPr>
+              <a:t> chỉ</a:t>
+            </a:r>
+            <a:r>
+              <a:rPr lang="en-US" sz="2250" dirty="0" spc="-11" kern="0">
+                <a:solidFill>
+                  <a:srgbClr val="C4C8D6"/>
+                </a:solidFill>
+                <a:latin typeface="Be Vietnam Pro" pitchFamily="34" charset="0"/>
+                <a:ea typeface="Be Vietnam Pro" pitchFamily="34" charset="-122"/>
+                <a:cs typeface="Be Vietnam Pro" pitchFamily="34" charset="-120"/>
+              </a:rPr>
+              <a:t> tên</a:t>
+            </a:r>
+            <a:r>
+              <a:rPr lang="en-US" sz="2250" dirty="0" spc="1" kern="0">
+                <a:solidFill>
+                  <a:srgbClr val="C4C8D6"/>
+                </a:solidFill>
+                <a:latin typeface="Be Vietnam Pro" pitchFamily="34" charset="0"/>
+                <a:ea typeface="Be Vietnam Pro" pitchFamily="34" charset="-122"/>
+                <a:cs typeface="Be Vietnam Pro" pitchFamily="34" charset="-120"/>
+              </a:rPr>
+              <a:t> vùng</a:t>
+            </a:r>
+            <a:r>
+              <a:rPr lang="en-US" sz="2250" dirty="0" spc="-1" kern="0">
+                <a:solidFill>
+                  <a:srgbClr val="C4C8D6"/>
+                </a:solidFill>
+                <a:latin typeface="Be Vietnam Pro" pitchFamily="34" charset="0"/>
+                <a:ea typeface="Be Vietnam Pro" pitchFamily="34" charset="-122"/>
+                <a:cs typeface="Be Vietnam Pro" pitchFamily="34" charset="-120"/>
+              </a:rPr>
+              <a:t> là</a:t>
+            </a:r>
+            <a:r>
+              <a:rPr lang="en-US" sz="2250" dirty="0" spc="2" kern="0">
+                <a:solidFill>
+                  <a:srgbClr val="C4C8D6"/>
+                </a:solidFill>
+                <a:latin typeface="Be Vietnam Pro" pitchFamily="34" charset="0"/>
+                <a:ea typeface="Be Vietnam Pro" pitchFamily="34" charset="-122"/>
+                <a:cs typeface="Be Vietnam Pro" pitchFamily="34" charset="-120"/>
+              </a:rPr>
+              <a:t> của nguồn.</a:t>
+            </a:r>
+            <a:endParaRPr lang="en-US" sz="2250" dirty="0"/>
+          </a:p>
+        </p:txBody>
+      </p:sp>
+      <p:sp>
+        <p:nvSpPr>
+          <p:cNvPr id="35" name="Shape 33"/>
           <p:cNvSpPr/>
           <p:nvPr/>
         </p:nvSpPr>
@@ -19548,7 +19719,7 @@
       </p:sp>
       <p:pic>
         <p:nvPicPr>
-          <p:cNvPr id="35" name="Moda image moda-export-watermark-2fd9c44c-d219-45ad-94ad-cbe1dfae9107" descr="">    </p:cNvPr>
+          <p:cNvPr id="36" name="Moda image moda-export-watermark-2fd9c44c-d219-45ad-94ad-cbe1dfae9107" descr="">    </p:cNvPr>
           <p:cNvPicPr>
             <a:picLocks noChangeAspect="1"/>
           </p:cNvPicPr>

</xml_diff>

<commit_message>
Lessons sd-10-003 and sd-10-006: describe CI without automatic merging; rebuild the WebAssembly explanations from MDN
Co-Authored-By: Claude Sonnet 5.5 <noreply@anthropic.com>
Claude-Session: https://claude.ai/code/session_01E4oCkXXqBf2c7oMUzFxEr2
</commit_message>
<xml_diff>
--- a/system-design-101/vi/lessons/sd-10-003/slides/sd-10-003.pptx
+++ b/system-design-101/vi/lessons/sd-10-003/slides/sd-10-003.pptx
@@ -18399,7 +18399,7 @@
               <a:buNone/>
             </a:pPr>
             <a:r>
-              <a:rPr lang="en-US" sz="2250" dirty="0" spc="-110" kern="0">
+              <a:rPr lang="en-US" sz="2250" dirty="0" spc="3" kern="0">
                 <a:solidFill>
                   <a:srgbClr val="F3EEE3"/>
                 </a:solidFill>
@@ -18407,7 +18407,62 @@
                 <a:ea typeface="Be Vietnam Pro" pitchFamily="34" charset="-122"/>
                 <a:cs typeface="Be Vietnam Pro" pitchFamily="34" charset="-120"/>
               </a:rPr>
-              <a:t>Tự</a:t>
+              <a:t>Gộp</a:t>
+            </a:r>
+            <a:r>
+              <a:rPr lang="en-US" sz="2250" dirty="0" spc="-7" kern="0">
+                <a:solidFill>
+                  <a:srgbClr val="F3EEE3"/>
+                </a:solidFill>
+                <a:latin typeface="Be Vietnam Pro" pitchFamily="34" charset="0"/>
+                <a:ea typeface="Be Vietnam Pro" pitchFamily="34" charset="-122"/>
+                <a:cs typeface="Be Vietnam Pro" pitchFamily="34" charset="-120"/>
+              </a:rPr>
+              <a:t> thay</a:t>
+            </a:r>
+            <a:r>
+              <a:rPr lang="en-US" sz="2250" dirty="0" spc="12" kern="0">
+                <a:solidFill>
+                  <a:srgbClr val="F3EEE3"/>
+                </a:solidFill>
+                <a:latin typeface="Be Vietnam Pro" pitchFamily="34" charset="0"/>
+                <a:ea typeface="Be Vietnam Pro" pitchFamily="34" charset="-122"/>
+                <a:cs typeface="Be Vietnam Pro" pitchFamily="34" charset="-120"/>
+              </a:rPr>
+              <a:t> đổi</a:t>
+            </a:r>
+            <a:r>
+              <a:rPr lang="en-US" sz="2250" dirty="0" spc="6" kern="0">
+                <a:solidFill>
+                  <a:srgbClr val="F3EEE3"/>
+                </a:solidFill>
+                <a:latin typeface="Be Vietnam Pro" pitchFamily="34" charset="0"/>
+                <a:ea typeface="Be Vietnam Pro" pitchFamily="34" charset="-122"/>
+                <a:cs typeface="Be Vietnam Pro" pitchFamily="34" charset="-120"/>
+              </a:rPr>
+              <a:t> thường</a:t>
+            </a:r>
+            <a:r>
+              <a:rPr lang="en-US" sz="2250" dirty="0" spc="-13" kern="0">
+                <a:solidFill>
+                  <a:srgbClr val="F3EEE3"/>
+                </a:solidFill>
+                <a:latin typeface="Be Vietnam Pro" pitchFamily="34" charset="0"/>
+                <a:ea typeface="Be Vietnam Pro" pitchFamily="34" charset="-122"/>
+                <a:cs typeface="Be Vietnam Pro" pitchFamily="34" charset="-120"/>
+              </a:rPr>
+              <a:t> xuyên,</a:t>
+            </a:r>
+            <a:r>
+              <a:rPr lang="en-US" sz="2250" dirty="0" spc="3" kern="0">
+                <a:solidFill>
+                  <a:srgbClr val="F3EEE3"/>
+                </a:solidFill>
+                <a:latin typeface="Be Vietnam Pro" pitchFamily="34" charset="0"/>
+                <a:ea typeface="Be Vietnam Pro" pitchFamily="34" charset="-122"/>
+                <a:cs typeface="Be Vietnam Pro" pitchFamily="34" charset="-120"/>
+              </a:rPr>
+              <a:t> tự</a:t>
             </a:r>
             <a:r>
               <a:rPr lang="en-US" sz="2250" dirty="0" spc="11" kern="0">
@@ -18421,7 +18476,7 @@
               <a:t> động</a:t>
             </a:r>
             <a:r>
-              <a:rPr lang="en-US" sz="2250" dirty="0" spc="-8" kern="0">
+              <a:rPr lang="en-US" sz="2250" dirty="0" spc="20" kern="0">
                 <a:solidFill>
                   <a:srgbClr val="F3EEE3"/>
                 </a:solidFill>
@@ -18429,7 +18484,18 @@
                 <a:ea typeface="Be Vietnam Pro" pitchFamily="34" charset="-122"/>
                 <a:cs typeface="Be Vietnam Pro" pitchFamily="34" charset="-120"/>
               </a:rPr>
-              <a:t> gộp,</a:t>
+              <a:t> dựng</a:t>
+            </a:r>
+            <a:r>
+              <a:rPr lang="en-US" sz="2250" dirty="0" spc="-16" kern="0">
+                <a:solidFill>
+                  <a:srgbClr val="F3EEE3"/>
+                </a:solidFill>
+                <a:latin typeface="Be Vietnam Pro" pitchFamily="34" charset="0"/>
+                <a:ea typeface="Be Vietnam Pro" pitchFamily="34" charset="-122"/>
+                <a:cs typeface="Be Vietnam Pro" pitchFamily="34" charset="-120"/>
+              </a:rPr>
+              <a:t> và</a:t>
             </a:r>
             <a:r>
               <a:rPr lang="en-US" sz="2250" dirty="0" spc="-2" kern="0">
@@ -18443,7 +18509,7 @@
               <a:t> kiểm</a:t>
             </a:r>
             <a:r>
-              <a:rPr lang="en-US" sz="2250" dirty="0" spc="-24" kern="0">
+              <a:rPr lang="en-US" sz="2250" dirty="0" spc="-18" kern="0">
                 <a:solidFill>
                   <a:srgbClr val="F3EEE3"/>
                 </a:solidFill>
@@ -18451,51 +18517,7 @@
                 <a:ea typeface="Be Vietnam Pro" pitchFamily="34" charset="-122"/>
                 <a:cs typeface="Be Vietnam Pro" pitchFamily="34" charset="-120"/>
               </a:rPr>
-              <a:t> tra</a:t>
-            </a:r>
-            <a:r>
-              <a:rPr lang="en-US" sz="2250" dirty="0" spc="-1" kern="0">
-                <a:solidFill>
-                  <a:srgbClr val="F3EEE3"/>
-                </a:solidFill>
-                <a:latin typeface="Be Vietnam Pro" pitchFamily="34" charset="0"/>
-                <a:ea typeface="Be Vietnam Pro" pitchFamily="34" charset="-122"/>
-                <a:cs typeface="Be Vietnam Pro" pitchFamily="34" charset="-120"/>
-              </a:rPr>
-              <a:t> mã khi</a:t>
-            </a:r>
-            <a:r>
-              <a:rPr lang="en-US" sz="2250" dirty="0" spc="5" kern="0">
-                <a:solidFill>
-                  <a:srgbClr val="F3EEE3"/>
-                </a:solidFill>
-                <a:latin typeface="Be Vietnam Pro" pitchFamily="34" charset="0"/>
-                <a:ea typeface="Be Vietnam Pro" pitchFamily="34" charset="-122"/>
-                <a:cs typeface="Be Vietnam Pro" pitchFamily="34" charset="-120"/>
-              </a:rPr>
-              <a:t> có</a:t>
-            </a:r>
-            <a:r>
-              <a:rPr lang="en-US" sz="2250" dirty="0" spc="-7" kern="0">
-                <a:solidFill>
-                  <a:srgbClr val="F3EEE3"/>
-                </a:solidFill>
-                <a:latin typeface="Be Vietnam Pro" pitchFamily="34" charset="0"/>
-                <a:ea typeface="Be Vietnam Pro" pitchFamily="34" charset="-122"/>
-                <a:cs typeface="Be Vietnam Pro" pitchFamily="34" charset="-120"/>
-              </a:rPr>
-              <a:t> thay</a:t>
-            </a:r>
-            <a:r>
-              <a:rPr lang="en-US" sz="2250" dirty="0" spc="11" kern="0">
-                <a:solidFill>
-                  <a:srgbClr val="F3EEE3"/>
-                </a:solidFill>
-                <a:latin typeface="Be Vietnam Pro" pitchFamily="34" charset="0"/>
-                <a:ea typeface="Be Vietnam Pro" pitchFamily="34" charset="-122"/>
-                <a:cs typeface="Be Vietnam Pro" pitchFamily="34" charset="-120"/>
-              </a:rPr>
-              <a:t> đổi.</a:t>
+              <a:t> tra.</a:t>
             </a:r>
             <a:endParaRPr lang="en-US" sz="2250" dirty="0"/>
           </a:p>

</xml_diff>

<commit_message>
Lesson sd-10-003: do not present durable storage as part of every database, in the lesson and deck
Co-Authored-By: Claude Sonnet 5.5 <noreply@anthropic.com>
Claude-Session: https://claude.ai/code/session_01Y9NYFwg4CcDYEWi1zr53gi
</commit_message>
<xml_diff>
--- a/system-design-101/vi/lessons/sd-10-003/slides/sd-10-003.pptx
+++ b/system-design-101/vi/lessons/sd-10-003/slides/sd-10-003.pptx
@@ -7380,15 +7380,15 @@
               <a:t> cơ sở dữ liệu</a:t>
             </a:r>
             <a:r>
-              <a:rPr lang="en-US" sz="2550" dirty="0" spc="-3" kern="0">
-                <a:solidFill>
-                  <a:srgbClr val="14161C"/>
-                </a:solidFill>
-                <a:latin typeface="Be Vietnam Pro" pitchFamily="34" charset="0"/>
-                <a:ea typeface="Be Vietnam Pro" pitchFamily="34" charset="-122"/>
-                <a:cs typeface="Be Vietnam Pro" pitchFamily="34" charset="-120"/>
-              </a:rPr>
-              <a:t> giữ</a:t>
+              <a:rPr lang="en-US" sz="2550" dirty="0" spc="17" kern="0">
+                <a:solidFill>
+                  <a:srgbClr val="14161C"/>
+                </a:solidFill>
+                <a:latin typeface="Be Vietnam Pro" pitchFamily="34" charset="0"/>
+                <a:ea typeface="Be Vietnam Pro" pitchFamily="34" charset="-122"/>
+                <a:cs typeface="Be Vietnam Pro" pitchFamily="34" charset="-120"/>
+              </a:rPr>
+              <a:t> lưu</a:t>
             </a:r>
             <a:r>
               <a:rPr lang="en-US" sz="2550" dirty="0" spc="-2" kern="0">
@@ -7402,7 +7402,7 @@
               <a:t> dữ</a:t>
             </a:r>
             <a:r>
-              <a:rPr lang="en-US" sz="2550" dirty="0" spc="1" kern="0">
+              <a:rPr lang="en-US" sz="2550" dirty="0" spc="2" kern="0">
                 <a:solidFill>
                   <a:srgbClr val="14161C"/>
                 </a:solidFill>
@@ -7421,7 +7421,29 @@
                 <a:ea typeface="Be Vietnam Pro" pitchFamily="34" charset="-122"/>
                 <a:cs typeface="Be Vietnam Pro" pitchFamily="34" charset="-120"/>
               </a:rPr>
-              <a:t> bền.</a:t>
+              <a:t> có</a:t>
+            </a:r>
+            <a:r>
+              <a:rPr lang="en-US" sz="2550" dirty="0" spc="-16" kern="0">
+                <a:solidFill>
+                  <a:srgbClr val="14161C"/>
+                </a:solidFill>
+                <a:latin typeface="Be Vietnam Pro" pitchFamily="34" charset="0"/>
+                <a:ea typeface="Be Vietnam Pro" pitchFamily="34" charset="-122"/>
+                <a:cs typeface="Be Vietnam Pro" pitchFamily="34" charset="-120"/>
+              </a:rPr>
+              <a:t> tổ</a:t>
+            </a:r>
+            <a:r>
+              <a:rPr lang="en-US" sz="2550" dirty="0" spc="6" kern="0">
+                <a:solidFill>
+                  <a:srgbClr val="14161C"/>
+                </a:solidFill>
+                <a:latin typeface="Be Vietnam Pro" pitchFamily="34" charset="0"/>
+                <a:ea typeface="Be Vietnam Pro" pitchFamily="34" charset="-122"/>
+                <a:cs typeface="Be Vietnam Pro" pitchFamily="34" charset="-120"/>
+              </a:rPr>
+              <a:t> chức.</a:t>
             </a:r>
             <a:endParaRPr lang="en-US" sz="2550" dirty="0"/>
           </a:p>

</xml_diff>